<commit_message>
report: update deck with epoch-0 results + real throughput breakdown
Slide 8 (results): epoch 0 complete — accept_len 1.0->2.32 (still improving per recent-500-vs-
prior-500), loss 2.26->0.29; note the two crash fixes (block-size 6 off-by-one; val dataloader
fork-at-epoch-boundary). Slide 9 (throughput): steady 1.17s/step is misleading — EFFECTIVE ~4.8s
(4.1x), 630 vs 2.6k tok/s; spike overhead 75% breaks down as ~71% MoE recompile + ~19% checkpoint
save (EP-DCP gather) + ~4% real HS — two levers (padding + save-once/epoch) = ~3x. Slide 12:
throughput promoted to top of roadmap.
</commit_message>
<xml_diff>
--- a/docs/reports/dsv4_dspark_npu_report.pptx
+++ b/docs/reports/dsv4_dspark_npu_report.pptx
@@ -4584,7 +4584,7 @@
                 </a:solidFill>
                 <a:latin typeface="Calibri"/>
               </a:rPr>
-              <a:t>Critical path: stacked→per-expert weight converter (unblocks serve/eval) → full train→eval → fill converged numbers.</a:t>
+              <a:t>Throughput (biggest single win, ~3×): fixed-shape MoE padding (kills recompiles) + save once/epoch (done, one-liner).</a:t>
             </a:r>
           </a:p>
           <a:p>
@@ -4605,11 +4605,11 @@
             <a:r>
               <a:rPr sz="1600" b="0" i="0">
                 <a:solidFill>
-                  <a:srgbClr val="1B2538"/>
-                </a:solidFill>
-                <a:latin typeface="Calibri"/>
-              </a:rPr>
-              <a:t>Validation gates (cheap, CPU): structural parity · EP-invariance · overfit-one-batch · config guard.</a:t>
+                  <a:srgbClr val="2E6CF6"/>
+                </a:solidFill>
+                <a:latin typeface="Calibri"/>
+              </a:rPr>
+              <a:t>Critical path: stacked→per-expert weight converter (unblocks serve/eval) → full train→eval → fill converged numbers.</a:t>
             </a:r>
           </a:p>
           <a:p>
@@ -4634,7 +4634,7 @@
                 </a:solidFill>
                 <a:latin typeface="Calibri"/>
               </a:rPr>
-              <a:t>Performance: fixed-shape MoE padding (kill recompile spikes) · argsort AiCore fix · gradient checkpointing (→512 anchors).</a:t>
+              <a:t>Validation gates (cheap, CPU): structural parity · EP-invariance · overfit-one-batch · config guard.</a:t>
             </a:r>
           </a:p>
           <a:p>
@@ -4659,7 +4659,7 @@
                 </a:solidFill>
                 <a:latin typeface="Calibri"/>
               </a:rPr>
-              <a:t>Kernel: integrate the SWA Triton kernel into the training path (einsum → fused).</a:t>
+              <a:t>Perf follow-ups: argsort AiCore fix · gradient checkpointing (→512 anchors) · SWA Triton kernel into training.</a:t>
             </a:r>
           </a:p>
           <a:p>
@@ -7432,7 +7432,7 @@
                 </a:solidFill>
                 <a:latin typeface="Calibri"/>
               </a:rPr>
-              <a:t>Training results (in progress — block6 @ 196 anchors, EP8)</a:t>
+              <a:t>Training results — epoch 0 complete (block6 @ 196 anchors, EP8)</a:t>
             </a:r>
           </a:p>
         </p:txBody>
@@ -7447,7 +7447,7 @@
         </p:nvGraphicFramePr>
         <p:xfrm>
           <a:off x="548640" y="1417320"/>
-          <a:ext cx="11064240" cy="2194560"/>
+          <a:ext cx="11064240" cy="1828800"/>
         </p:xfrm>
         <a:graphic>
           <a:graphicData uri="http://schemas.openxmlformats.org/drawingml/2006/table">
@@ -7456,10 +7456,10 @@
                 <a:tableStyleId>{5C22544A-7EE6-4342-B048-85BDC9FD1C3A}</a:tableStyleId>
               </a:tblPr>
               <a:tblGrid>
-                <a:gridCol w="2743200"/>
-                <a:gridCol w="2743200"/>
-                <a:gridCol w="2743200"/>
-                <a:gridCol w="2834640"/>
+                <a:gridCol w="3017520"/>
+                <a:gridCol w="1737360"/>
+                <a:gridCol w="4389120"/>
+                <a:gridCol w="1920240"/>
               </a:tblGrid>
               <a:tr h="365760">
                 <a:tc>
@@ -7496,7 +7496,7 @@
                           </a:solidFill>
                           <a:latin typeface="Calibri"/>
                         </a:rPr>
-                        <a:t>@ step ~1.1k</a:t>
+                        <a:t>start</a:t>
                       </a:r>
                     </a:p>
                   </a:txBody>
@@ -7518,7 +7518,7 @@
                           </a:solidFill>
                           <a:latin typeface="Calibri"/>
                         </a:rPr>
-                        <a:t>@ step ~3.9k</a:t>
+                        <a:t>end of epoch 0</a:t>
                       </a:r>
                     </a:p>
                   </a:txBody>
@@ -7586,7 +7586,7 @@
                           </a:solidFill>
                           <a:latin typeface="Calibri"/>
                         </a:rPr>
-                        <a:t>0.46</a:t>
+                        <a:t>2.26</a:t>
                       </a:r>
                     </a:p>
                   </a:txBody>
@@ -7676,7 +7676,7 @@
                           </a:solidFill>
                           <a:latin typeface="Calibri"/>
                         </a:rPr>
-                        <a:t>1.19</a:t>
+                        <a:t>1.0</a:t>
                       </a:r>
                     </a:p>
                   </a:txBody>
@@ -7698,7 +7698,7 @@
                           </a:solidFill>
                           <a:latin typeface="Calibri"/>
                         </a:rPr>
-                        <a:t>2.5 ↑</a:t>
+                        <a:t>2.32 ↑ (max 2.71)</a:t>
                       </a:r>
                     </a:p>
                   </a:txBody>
@@ -7744,7 +7744,7 @@
                           </a:solidFill>
                           <a:latin typeface="Calibri"/>
                         </a:rPr>
-                        <a:t>position_1_acc</a:t>
+                        <a:t>position_1..5 acc</a:t>
                       </a:r>
                     </a:p>
                   </a:txBody>
@@ -7766,7 +7766,7 @@
                           </a:solidFill>
                           <a:latin typeface="Calibri"/>
                         </a:rPr>
-                        <a:t>0.41</a:t>
+                        <a:t>—</a:t>
                       </a:r>
                     </a:p>
                   </a:txBody>
@@ -7788,7 +7788,7 @@
                           </a:solidFill>
                           <a:latin typeface="Calibri"/>
                         </a:rPr>
-                        <a:t>0.70</a:t>
+                        <a:t>0.65 / 0.49 / 0.37 / 0.31 / 0.27</a:t>
                       </a:r>
                     </a:p>
                   </a:txBody>
@@ -7834,7 +7834,7 @@
                           </a:solidFill>
                           <a:latin typeface="Calibri"/>
                         </a:rPr>
-                        <a:t>position_5_acc</a:t>
+                        <a:t>confidence pred vs obs</a:t>
                       </a:r>
                     </a:p>
                   </a:txBody>
@@ -7878,7 +7878,7 @@
                           </a:solidFill>
                           <a:latin typeface="Calibri"/>
                         </a:rPr>
-                        <a:t>0.28</a:t>
+                        <a:t>0.20 vs 0.38</a:t>
                       </a:r>
                     </a:p>
                   </a:txBody>
@@ -7900,103 +7900,13 @@
                           </a:solidFill>
                           <a:latin typeface="Calibri"/>
                         </a:rPr>
-                        <a:t>—</a:t>
+                        <a:t>calibrate</a:t>
                       </a:r>
                     </a:p>
                   </a:txBody>
                   <a:tcPr>
                     <a:solidFill>
                       <a:srgbClr val="FFFFFF"/>
-                    </a:solidFill>
-                  </a:tcPr>
-                </a:tc>
-              </a:tr>
-              <a:tr h="365760">
-                <a:tc>
-                  <a:txBody>
-                    <a:bodyPr/>
-                    <a:lstStyle/>
-                    <a:p>
-                      <a:r>
-                        <a:rPr sz="1300" b="0" i="0">
-                          <a:solidFill>
-                            <a:srgbClr val="1B2538"/>
-                          </a:solidFill>
-                          <a:latin typeface="Calibri"/>
-                        </a:rPr>
-                        <a:t>confidence_loss</a:t>
-                      </a:r>
-                    </a:p>
-                  </a:txBody>
-                  <a:tcPr>
-                    <a:solidFill>
-                      <a:srgbClr val="F5F7FA"/>
-                    </a:solidFill>
-                  </a:tcPr>
-                </a:tc>
-                <a:tc>
-                  <a:txBody>
-                    <a:bodyPr/>
-                    <a:lstStyle/>
-                    <a:p>
-                      <a:r>
-                        <a:rPr sz="1300" b="0" i="0">
-                          <a:solidFill>
-                            <a:srgbClr val="1B2538"/>
-                          </a:solidFill>
-                          <a:latin typeface="Calibri"/>
-                        </a:rPr>
-                        <a:t>0.28</a:t>
-                      </a:r>
-                    </a:p>
-                  </a:txBody>
-                  <a:tcPr>
-                    <a:solidFill>
-                      <a:srgbClr val="F5F7FA"/>
-                    </a:solidFill>
-                  </a:tcPr>
-                </a:tc>
-                <a:tc>
-                  <a:txBody>
-                    <a:bodyPr/>
-                    <a:lstStyle/>
-                    <a:p>
-                      <a:r>
-                        <a:rPr sz="1300" b="0" i="0">
-                          <a:solidFill>
-                            <a:srgbClr val="1B2538"/>
-                          </a:solidFill>
-                          <a:latin typeface="Calibri"/>
-                        </a:rPr>
-                        <a:t>0.30</a:t>
-                      </a:r>
-                    </a:p>
-                  </a:txBody>
-                  <a:tcPr>
-                    <a:solidFill>
-                      <a:srgbClr val="F5F7FA"/>
-                    </a:solidFill>
-                  </a:tcPr>
-                </a:tc>
-                <a:tc>
-                  <a:txBody>
-                    <a:bodyPr/>
-                    <a:lstStyle/>
-                    <a:p>
-                      <a:r>
-                        <a:rPr sz="1300" b="0" i="0">
-                          <a:solidFill>
-                            <a:srgbClr val="1B2538"/>
-                          </a:solidFill>
-                          <a:latin typeface="Calibri"/>
-                        </a:rPr>
-                        <a:t>calibrated</a:t>
-                      </a:r>
-                    </a:p>
-                  </a:txBody>
-                  <a:tcPr>
-                    <a:solidFill>
-                      <a:srgbClr val="F5F7FA"/>
                     </a:solidFill>
                   </a:tcPr>
                 </a:tc>
@@ -8013,7 +7923,7 @@
         </p:nvSpPr>
         <p:spPr>
           <a:xfrm>
-            <a:off x="548640" y="3931920"/>
+            <a:off x="548640" y="3794760"/>
             <a:ext cx="11064240" cy="5120640"/>
           </a:xfrm>
           <a:prstGeom prst="rect">
@@ -8049,7 +7959,7 @@
                 </a:solidFill>
                 <a:latin typeface="Calibri"/>
               </a:rPr>
-              <a:t>Draft is learning steadily; accept_len climbing toward the 3.94 released-draft bar.</a:t>
+              <a:t>Still learning at epoch end — recent-500 vs prior-500: loss↓, accept_len↑, full_acc↑ (not plateaued).</a:t>
             </a:r>
           </a:p>
           <a:p>
@@ -8074,7 +7984,7 @@
                 </a:solidFill>
                 <a:latin typeface="Calibri"/>
               </a:rPr>
-              <a:t>Memory: 59 GB reserved / 64 (92%) — fits with the block-6, 196-anchor config on 8×A2.</a:t>
+              <a:t>accept_len 2.32 after 1 epoch (of 20); climbing toward the released-draft 3.94 — needs more epochs.</a:t>
             </a:r>
           </a:p>
           <a:p>
@@ -8099,7 +8009,57 @@
                 </a:solidFill>
                 <a:latin typeface="Calibri"/>
               </a:rPr>
-              <a:t>Converged per-benchmark numbers pending a full train→eval pass (needs the stacked→per-expert converter).</a:t>
+              <a:t>Memory 59 GB / 64 (92%). Two crash bugs fixed this run: --block-size 6 (off-by-one) and the val</a:t>
+            </a:r>
+          </a:p>
+          <a:p>
+            <a:pPr lvl="1">
+              <a:spcAft>
+                <a:spcPts val="600"/>
+              </a:spcAft>
+            </a:pPr>
+            <a:r>
+              <a:rPr sz="1600" b="1" i="0">
+                <a:solidFill>
+                  <a:srgbClr val="5A6678"/>
+                </a:solidFill>
+                <a:latin typeface="Calibri"/>
+              </a:rPr>
+              <a:t>–  </a:t>
+            </a:r>
+            <a:r>
+              <a:rPr sz="1500" b="0" i="0">
+                <a:solidFill>
+                  <a:srgbClr val="1B2538"/>
+                </a:solidFill>
+                <a:latin typeface="Calibri"/>
+              </a:rPr>
+              <a:t>dataloader fork-at-epoch-boundary (num_workers=0); training now survives epoch boundaries + resumes.</a:t>
+            </a:r>
+          </a:p>
+          <a:p>
+            <a:pPr>
+              <a:spcAft>
+                <a:spcPts val="600"/>
+              </a:spcAft>
+            </a:pPr>
+            <a:r>
+              <a:rPr sz="1600" b="1" i="0">
+                <a:solidFill>
+                  <a:srgbClr val="2E6CF6"/>
+                </a:solidFill>
+                <a:latin typeface="Calibri"/>
+              </a:rPr>
+              <a:t>•  </a:t>
+            </a:r>
+            <a:r>
+              <a:rPr sz="1600" b="0" i="0">
+                <a:solidFill>
+                  <a:srgbClr val="1B2538"/>
+                </a:solidFill>
+                <a:latin typeface="Calibri"/>
+              </a:rPr>
+              <a:t>Converged per-benchmark numbers pending train→eval (needs the stacked→per-expert converter).</a:t>
             </a:r>
           </a:p>
         </p:txBody>
@@ -8248,7 +8208,7 @@
                 </a:solidFill>
                 <a:latin typeface="Calibri"/>
               </a:rPr>
-              <a:t>Throughput &amp; timing</a:t>
+              <a:t>Throughput — steady is a lie; spikes eat 75% of wall-clock</a:t>
             </a:r>
           </a:p>
         </p:txBody>
@@ -8262,8 +8222,8 @@
           <p:nvPr/>
         </p:nvGraphicFramePr>
         <p:xfrm>
-          <a:off x="548640" y="1417320"/>
-          <a:ext cx="11064240" cy="2194560"/>
+          <a:off x="548640" y="1371600"/>
+          <a:ext cx="11064240" cy="1463040"/>
         </p:xfrm>
         <a:graphic>
           <a:graphicData uri="http://schemas.openxmlformats.org/drawingml/2006/table">
@@ -8272,9 +8232,9 @@
                 <a:tableStyleId>{5C22544A-7EE6-4342-B048-85BDC9FD1C3A}</a:tableStyleId>
               </a:tblPr>
               <a:tblGrid>
-                <a:gridCol w="2926080"/>
-                <a:gridCol w="2011680"/>
-                <a:gridCol w="6126480"/>
+                <a:gridCol w="3108960"/>
+                <a:gridCol w="3931920"/>
+                <a:gridCol w="4023360"/>
               </a:tblGrid>
               <a:tr h="365760">
                 <a:tc>
@@ -8289,7 +8249,7 @@
                           </a:solidFill>
                           <a:latin typeface="Calibri"/>
                         </a:rPr>
-                        <a:t>stage (steady)</a:t>
+                        <a:t/>
                       </a:r>
                     </a:p>
                   </a:txBody>
@@ -8311,7 +8271,7 @@
                           </a:solidFill>
                           <a:latin typeface="Calibri"/>
                         </a:rPr>
-                        <a:t>time</a:t>
+                        <a:t>steady (spikes excluded)</a:t>
                       </a:r>
                     </a:p>
                   </a:txBody>
@@ -8333,7 +8293,7 @@
                           </a:solidFill>
                           <a:latin typeface="Calibri"/>
                         </a:rPr>
-                        <a:t>note</a:t>
+                        <a:t>EFFECTIVE (real, incl spikes)</a:t>
                       </a:r>
                     </a:p>
                   </a:txBody>
@@ -8357,7 +8317,7 @@
                           </a:solidFill>
                           <a:latin typeface="Calibri"/>
                         </a:rPr>
-                        <a:t>forward</a:t>
+                        <a:t>step time</a:t>
                       </a:r>
                     </a:p>
                   </a:txBody>
@@ -8379,7 +8339,7 @@
                           </a:solidFill>
                           <a:latin typeface="Calibri"/>
                         </a:rPr>
-                        <a:t>~375 ms</a:t>
+                        <a:t>~1.17 s</a:t>
                       </a:r>
                     </a:p>
                   </a:txBody>
@@ -8401,7 +8361,7 @@
                           </a:solidFill>
                           <a:latin typeface="Calibri"/>
                         </a:rPr>
-                        <a:t>MoE + sink attention</a:t>
+                        <a:t>~4.8 s  (4.1×)</a:t>
                       </a:r>
                     </a:p>
                   </a:txBody>
@@ -8425,7 +8385,7 @@
                           </a:solidFill>
                           <a:latin typeface="Calibri"/>
                         </a:rPr>
-                        <a:t>backward</a:t>
+                        <a:t>throughput</a:t>
                       </a:r>
                     </a:p>
                   </a:txBody>
@@ -8447,7 +8407,7 @@
                           </a:solidFill>
                           <a:latin typeface="Calibri"/>
                         </a:rPr>
-                        <a:t>~620 ms</a:t>
+                        <a:t>~2.6k tok/s</a:t>
                       </a:r>
                     </a:p>
                   </a:txBody>
@@ -8469,7 +8429,7 @@
                           </a:solidFill>
                           <a:latin typeface="Calibri"/>
                         </a:rPr>
-                        <a:t>dominates steady state</a:t>
+                        <a:t>~630 tok/s</a:t>
                       </a:r>
                     </a:p>
                   </a:txBody>
@@ -8493,7 +8453,7 @@
                           </a:solidFill>
                           <a:latin typeface="Calibri"/>
                         </a:rPr>
-                        <a:t>optimizer</a:t>
+                        <a:t>1 epoch (4416 steps)</a:t>
                       </a:r>
                     </a:p>
                   </a:txBody>
@@ -8515,7 +8475,7 @@
                           </a:solidFill>
                           <a:latin typeface="Calibri"/>
                         </a:rPr>
-                        <a:t>~100 ms</a:t>
+                        <a:t>(would be ~1.4 h)</a:t>
                       </a:r>
                     </a:p>
                   </a:txBody>
@@ -8537,143 +8497,7 @@
                           </a:solidFill>
                           <a:latin typeface="Calibri"/>
                         </a:rPr>
-                        <a:t>single AdamW over DTensors</a:t>
-                      </a:r>
-                    </a:p>
-                  </a:txBody>
-                  <a:tcPr>
-                    <a:solidFill>
-                      <a:srgbClr val="F5F7FA"/>
-                    </a:solidFill>
-                  </a:tcPr>
-                </a:tc>
-              </a:tr>
-              <a:tr h="365760">
-                <a:tc>
-                  <a:txBody>
-                    <a:bodyPr/>
-                    <a:lstStyle/>
-                    <a:p>
-                      <a:r>
-                        <a:rPr sz="1300" b="0" i="0">
-                          <a:solidFill>
-                            <a:srgbClr val="1B2538"/>
-                          </a:solidFill>
-                          <a:latin typeface="Calibri"/>
-                        </a:rPr>
-                        <a:t>HS fetch</a:t>
-                      </a:r>
-                    </a:p>
-                  </a:txBody>
-                  <a:tcPr>
-                    <a:solidFill>
-                      <a:srgbClr val="FFFFFF"/>
-                    </a:solidFill>
-                  </a:tcPr>
-                </a:tc>
-                <a:tc>
-                  <a:txBody>
-                    <a:bodyPr/>
-                    <a:lstStyle/>
-                    <a:p>
-                      <a:r>
-                        <a:rPr sz="1300" b="0" i="0">
-                          <a:solidFill>
-                            <a:srgbClr val="1B2538"/>
-                          </a:solidFill>
-                          <a:latin typeface="Calibri"/>
-                        </a:rPr>
-                        <a:t>~27 ms</a:t>
-                      </a:r>
-                    </a:p>
-                  </a:txBody>
-                  <a:tcPr>
-                    <a:solidFill>
-                      <a:srgbClr val="FFFFFF"/>
-                    </a:solidFill>
-                  </a:tcPr>
-                </a:tc>
-                <a:tc>
-                  <a:txBody>
-                    <a:bodyPr/>
-                    <a:lstStyle/>
-                    <a:p>
-                      <a:r>
-                        <a:rPr sz="1300" b="0" i="0">
-                          <a:solidFill>
-                            <a:srgbClr val="1B2538"/>
-                          </a:solidFill>
-                          <a:latin typeface="Calibri"/>
-                        </a:rPr>
-                        <a:t>fetch_frac 0.02 — NOT a bottleneck</a:t>
-                      </a:r>
-                    </a:p>
-                  </a:txBody>
-                  <a:tcPr>
-                    <a:solidFill>
-                      <a:srgbClr val="FFFFFF"/>
-                    </a:solidFill>
-                  </a:tcPr>
-                </a:tc>
-              </a:tr>
-              <a:tr h="365760">
-                <a:tc>
-                  <a:txBody>
-                    <a:bodyPr/>
-                    <a:lstStyle/>
-                    <a:p>
-                      <a:r>
-                        <a:rPr sz="1300" b="0" i="0">
-                          <a:solidFill>
-                            <a:srgbClr val="1B2538"/>
-                          </a:solidFill>
-                          <a:latin typeface="Calibri"/>
-                        </a:rPr>
-                        <a:t>step</a:t>
-                      </a:r>
-                    </a:p>
-                  </a:txBody>
-                  <a:tcPr>
-                    <a:solidFill>
-                      <a:srgbClr val="F5F7FA"/>
-                    </a:solidFill>
-                  </a:tcPr>
-                </a:tc>
-                <a:tc>
-                  <a:txBody>
-                    <a:bodyPr/>
-                    <a:lstStyle/>
-                    <a:p>
-                      <a:r>
-                        <a:rPr sz="1300" b="0" i="0">
-                          <a:solidFill>
-                            <a:srgbClr val="1B2538"/>
-                          </a:solidFill>
-                          <a:latin typeface="Calibri"/>
-                        </a:rPr>
-                        <a:t>~1.13 s</a:t>
-                      </a:r>
-                    </a:p>
-                  </a:txBody>
-                  <a:tcPr>
-                    <a:solidFill>
-                      <a:srgbClr val="F5F7FA"/>
-                    </a:solidFill>
-                  </a:tcPr>
-                </a:tc>
-                <a:tc>
-                  <a:txBody>
-                    <a:bodyPr/>
-                    <a:lstStyle/>
-                    <a:p>
-                      <a:r>
-                        <a:rPr sz="1300" b="0" i="0">
-                          <a:solidFill>
-                            <a:srgbClr val="1B2538"/>
-                          </a:solidFill>
-                          <a:latin typeface="Calibri"/>
-                        </a:rPr>
-                        <a:t>≈ 2.6k tokens/s</a:t>
+                        <a:t>5.8 h</a:t>
                       </a:r>
                     </a:p>
                   </a:txBody>
@@ -8696,7 +8520,429 @@
         </p:nvSpPr>
         <p:spPr>
           <a:xfrm>
-            <a:off x="548640" y="3977639"/>
+            <a:off x="548640" y="2788920"/>
+            <a:ext cx="11064240" cy="365760"/>
+          </a:xfrm>
+          <a:prstGeom prst="rect">
+            <a:avLst/>
+          </a:prstGeom>
+          <a:noFill/>
+        </p:spPr>
+        <p:txBody>
+          <a:bodyPr wrap="square">
+            <a:spAutoFit/>
+          </a:bodyPr>
+          <a:lstStyle/>
+          <a:p>
+            <a:r>
+              <a:rPr sz="1500" b="1" i="0">
+                <a:solidFill>
+                  <a:srgbClr val="1B2538"/>
+                </a:solidFill>
+                <a:latin typeface="Calibri"/>
+              </a:rPr>
+              <a:t>Spike overhead ≈ 15,700 s / epoch (75% of wall-clock) breaks down as:</a:t>
+            </a:r>
+          </a:p>
+        </p:txBody>
+      </p:sp>
+      <p:graphicFrame>
+        <p:nvGraphicFramePr>
+          <p:cNvPr id="6" name="Table 5"/>
+          <p:cNvGraphicFramePr>
+            <a:graphicFrameLocks noGrp="1"/>
+          </p:cNvGraphicFramePr>
+          <p:nvPr/>
+        </p:nvGraphicFramePr>
+        <p:xfrm>
+          <a:off x="548640" y="3200400"/>
+          <a:ext cx="11704320" cy="1463040"/>
+        </p:xfrm>
+        <a:graphic>
+          <a:graphicData uri="http://schemas.openxmlformats.org/drawingml/2006/table">
+            <a:tbl>
+              <a:tblPr firstRow="1" bandRow="1">
+                <a:tableStyleId>{5C22544A-7EE6-4342-B048-85BDC9FD1C3A}</a:tableStyleId>
+              </a:tblPr>
+              <a:tblGrid>
+                <a:gridCol w="4572000"/>
+                <a:gridCol w="2194560"/>
+                <a:gridCol w="2194560"/>
+                <a:gridCol w="2743200"/>
+              </a:tblGrid>
+              <a:tr h="365760">
+                <a:tc>
+                  <a:txBody>
+                    <a:bodyPr/>
+                    <a:lstStyle/>
+                    <a:p>
+                      <a:r>
+                        <a:rPr sz="1200" b="1" i="0">
+                          <a:solidFill>
+                            <a:srgbClr val="FFFFFF"/>
+                          </a:solidFill>
+                          <a:latin typeface="Calibri"/>
+                        </a:rPr>
+                        <a:t>cause</a:t>
+                      </a:r>
+                    </a:p>
+                  </a:txBody>
+                  <a:tcPr>
+                    <a:solidFill>
+                      <a:srgbClr val="1B2538"/>
+                    </a:solidFill>
+                  </a:tcPr>
+                </a:tc>
+                <a:tc>
+                  <a:txBody>
+                    <a:bodyPr/>
+                    <a:lstStyle/>
+                    <a:p>
+                      <a:r>
+                        <a:rPr sz="1200" b="1" i="0">
+                          <a:solidFill>
+                            <a:srgbClr val="FFFFFF"/>
+                          </a:solidFill>
+                          <a:latin typeface="Calibri"/>
+                        </a:rPr>
+                        <a:t>count × each</a:t>
+                      </a:r>
+                    </a:p>
+                  </a:txBody>
+                  <a:tcPr>
+                    <a:solidFill>
+                      <a:srgbClr val="1B2538"/>
+                    </a:solidFill>
+                  </a:tcPr>
+                </a:tc>
+                <a:tc>
+                  <a:txBody>
+                    <a:bodyPr/>
+                    <a:lstStyle/>
+                    <a:p>
+                      <a:r>
+                        <a:rPr sz="1200" b="1" i="0">
+                          <a:solidFill>
+                            <a:srgbClr val="FFFFFF"/>
+                          </a:solidFill>
+                          <a:latin typeface="Calibri"/>
+                        </a:rPr>
+                        <a:t>cost</a:t>
+                      </a:r>
+                    </a:p>
+                  </a:txBody>
+                  <a:tcPr>
+                    <a:solidFill>
+                      <a:srgbClr val="1B2538"/>
+                    </a:solidFill>
+                  </a:tcPr>
+                </a:tc>
+                <a:tc>
+                  <a:txBody>
+                    <a:bodyPr/>
+                    <a:lstStyle/>
+                    <a:p>
+                      <a:r>
+                        <a:rPr sz="1200" b="1" i="0">
+                          <a:solidFill>
+                            <a:srgbClr val="FFFFFF"/>
+                          </a:solidFill>
+                          <a:latin typeface="Calibri"/>
+                        </a:rPr>
+                        <a:t>fix</a:t>
+                      </a:r>
+                    </a:p>
+                  </a:txBody>
+                  <a:tcPr>
+                    <a:solidFill>
+                      <a:srgbClr val="1B2538"/>
+                    </a:solidFill>
+                  </a:tcPr>
+                </a:tc>
+              </a:tr>
+              <a:tr h="365760">
+                <a:tc>
+                  <a:txBody>
+                    <a:bodyPr/>
+                    <a:lstStyle/>
+                    <a:p>
+                      <a:r>
+                        <a:rPr sz="1200" b="0" i="0">
+                          <a:solidFill>
+                            <a:srgbClr val="1B2538"/>
+                          </a:solidFill>
+                          <a:latin typeface="Calibri"/>
+                        </a:rPr>
+                        <a:t>MoE recompile (new token-count shapes)</a:t>
+                      </a:r>
+                    </a:p>
+                  </a:txBody>
+                  <a:tcPr>
+                    <a:solidFill>
+                      <a:srgbClr val="F5F7FA"/>
+                    </a:solidFill>
+                  </a:tcPr>
+                </a:tc>
+                <a:tc>
+                  <a:txBody>
+                    <a:bodyPr/>
+                    <a:lstStyle/>
+                    <a:p>
+                      <a:r>
+                        <a:rPr sz="1200" b="0" i="0">
+                          <a:solidFill>
+                            <a:srgbClr val="1B2538"/>
+                          </a:solidFill>
+                          <a:latin typeface="Calibri"/>
+                        </a:rPr>
+                        <a:t>~623 × ~18 s</a:t>
+                      </a:r>
+                    </a:p>
+                  </a:txBody>
+                  <a:tcPr>
+                    <a:solidFill>
+                      <a:srgbClr val="F5F7FA"/>
+                    </a:solidFill>
+                  </a:tcPr>
+                </a:tc>
+                <a:tc>
+                  <a:txBody>
+                    <a:bodyPr/>
+                    <a:lstStyle/>
+                    <a:p>
+                      <a:r>
+                        <a:rPr sz="1200" b="0" i="0">
+                          <a:solidFill>
+                            <a:srgbClr val="1B2538"/>
+                          </a:solidFill>
+                          <a:latin typeface="Calibri"/>
+                        </a:rPr>
+                        <a:t>~11.2k s (71%)</a:t>
+                      </a:r>
+                    </a:p>
+                  </a:txBody>
+                  <a:tcPr>
+                    <a:solidFill>
+                      <a:srgbClr val="F5F7FA"/>
+                    </a:solidFill>
+                  </a:tcPr>
+                </a:tc>
+                <a:tc>
+                  <a:txBody>
+                    <a:bodyPr/>
+                    <a:lstStyle/>
+                    <a:p>
+                      <a:r>
+                        <a:rPr sz="1200" b="0" i="0">
+                          <a:solidFill>
+                            <a:srgbClr val="1B2538"/>
+                          </a:solidFill>
+                          <a:latin typeface="Calibri"/>
+                        </a:rPr>
+                        <a:t>fixed-shape MoE padding</a:t>
+                      </a:r>
+                    </a:p>
+                  </a:txBody>
+                  <a:tcPr>
+                    <a:solidFill>
+                      <a:srgbClr val="F5F7FA"/>
+                    </a:solidFill>
+                  </a:tcPr>
+                </a:tc>
+              </a:tr>
+              <a:tr h="365760">
+                <a:tc>
+                  <a:txBody>
+                    <a:bodyPr/>
+                    <a:lstStyle/>
+                    <a:p>
+                      <a:r>
+                        <a:rPr sz="1200" b="0" i="0">
+                          <a:solidFill>
+                            <a:srgbClr val="1B2538"/>
+                          </a:solidFill>
+                          <a:latin typeface="Calibri"/>
+                        </a:rPr>
+                        <a:t>checkpoint save (EP-DCP gather)</a:t>
+                      </a:r>
+                    </a:p>
+                  </a:txBody>
+                  <a:tcPr>
+                    <a:solidFill>
+                      <a:srgbClr val="FFFFFF"/>
+                    </a:solidFill>
+                  </a:tcPr>
+                </a:tc>
+                <a:tc>
+                  <a:txBody>
+                    <a:bodyPr/>
+                    <a:lstStyle/>
+                    <a:p>
+                      <a:r>
+                        <a:rPr sz="1200" b="0" i="0">
+                          <a:solidFill>
+                            <a:srgbClr val="1B2538"/>
+                          </a:solidFill>
+                          <a:latin typeface="Calibri"/>
+                        </a:rPr>
+                        <a:t>~10 × ~300 s</a:t>
+                      </a:r>
+                    </a:p>
+                  </a:txBody>
+                  <a:tcPr>
+                    <a:solidFill>
+                      <a:srgbClr val="FFFFFF"/>
+                    </a:solidFill>
+                  </a:tcPr>
+                </a:tc>
+                <a:tc>
+                  <a:txBody>
+                    <a:bodyPr/>
+                    <a:lstStyle/>
+                    <a:p>
+                      <a:r>
+                        <a:rPr sz="1200" b="0" i="0">
+                          <a:solidFill>
+                            <a:srgbClr val="1B2538"/>
+                          </a:solidFill>
+                          <a:latin typeface="Calibri"/>
+                        </a:rPr>
+                        <a:t>~3.0k s (19%)</a:t>
+                      </a:r>
+                    </a:p>
+                  </a:txBody>
+                  <a:tcPr>
+                    <a:solidFill>
+                      <a:srgbClr val="FFFFFF"/>
+                    </a:solidFill>
+                  </a:tcPr>
+                </a:tc>
+                <a:tc>
+                  <a:txBody>
+                    <a:bodyPr/>
+                    <a:lstStyle/>
+                    <a:p>
+                      <a:r>
+                        <a:rPr sz="1200" b="0" i="0">
+                          <a:solidFill>
+                            <a:srgbClr val="1B2538"/>
+                          </a:solidFill>
+                          <a:latin typeface="Calibri"/>
+                        </a:rPr>
+                        <a:t>raise --checkpoint-freq (→1/epoch)</a:t>
+                      </a:r>
+                    </a:p>
+                  </a:txBody>
+                  <a:tcPr>
+                    <a:solidFill>
+                      <a:srgbClr val="FFFFFF"/>
+                    </a:solidFill>
+                  </a:tcPr>
+                </a:tc>
+              </a:tr>
+              <a:tr h="365760">
+                <a:tc>
+                  <a:txBody>
+                    <a:bodyPr/>
+                    <a:lstStyle/>
+                    <a:p>
+                      <a:r>
+                        <a:rPr sz="1200" b="0" i="0">
+                          <a:solidFill>
+                            <a:srgbClr val="1B2538"/>
+                          </a:solidFill>
+                          <a:latin typeface="Calibri"/>
+                        </a:rPr>
+                        <a:t>real HS starvation</a:t>
+                      </a:r>
+                    </a:p>
+                  </a:txBody>
+                  <a:tcPr>
+                    <a:solidFill>
+                      <a:srgbClr val="F5F7FA"/>
+                    </a:solidFill>
+                  </a:tcPr>
+                </a:tc>
+                <a:tc>
+                  <a:txBody>
+                    <a:bodyPr/>
+                    <a:lstStyle/>
+                    <a:p>
+                      <a:r>
+                        <a:rPr sz="1200" b="0" i="0">
+                          <a:solidFill>
+                            <a:srgbClr val="1B2538"/>
+                          </a:solidFill>
+                          <a:latin typeface="Calibri"/>
+                        </a:rPr>
+                        <a:t>~2 × ~300 s</a:t>
+                      </a:r>
+                    </a:p>
+                  </a:txBody>
+                  <a:tcPr>
+                    <a:solidFill>
+                      <a:srgbClr val="F5F7FA"/>
+                    </a:solidFill>
+                  </a:tcPr>
+                </a:tc>
+                <a:tc>
+                  <a:txBody>
+                    <a:bodyPr/>
+                    <a:lstStyle/>
+                    <a:p>
+                      <a:r>
+                        <a:rPr sz="1200" b="0" i="0">
+                          <a:solidFill>
+                            <a:srgbClr val="1B2538"/>
+                          </a:solidFill>
+                          <a:latin typeface="Calibri"/>
+                        </a:rPr>
+                        <a:t>~0.6k s (4%)</a:t>
+                      </a:r>
+                    </a:p>
+                  </a:txBody>
+                  <a:tcPr>
+                    <a:solidFill>
+                      <a:srgbClr val="F5F7FA"/>
+                    </a:solidFill>
+                  </a:tcPr>
+                </a:tc>
+                <a:tc>
+                  <a:txBody>
+                    <a:bodyPr/>
+                    <a:lstStyle/>
+                    <a:p>
+                      <a:r>
+                        <a:rPr sz="1200" b="0" i="0">
+                          <a:solidFill>
+                            <a:srgbClr val="1B2538"/>
+                          </a:solidFill>
+                          <a:latin typeface="Calibri"/>
+                        </a:rPr>
+                        <a:t>serve throughput (minor)</a:t>
+                      </a:r>
+                    </a:p>
+                  </a:txBody>
+                  <a:tcPr>
+                    <a:solidFill>
+                      <a:srgbClr val="F5F7FA"/>
+                    </a:solidFill>
+                  </a:tcPr>
+                </a:tc>
+              </a:tr>
+            </a:tbl>
+          </a:graphicData>
+        </a:graphic>
+      </p:graphicFrame>
+      <p:sp>
+        <p:nvSpPr>
+          <p:cNvPr id="7" name="TextBox 6"/>
+          <p:cNvSpPr txBox="1"/>
+          <p:nvPr/>
+        </p:nvSpPr>
+        <p:spPr>
+          <a:xfrm>
+            <a:off x="548640" y="5074920"/>
             <a:ext cx="11064240" cy="5120640"/>
           </a:xfrm>
           <a:prstGeom prst="rect">
@@ -8728,11 +8974,11 @@
             <a:r>
               <a:rPr sz="1600" b="0" i="0">
                 <a:solidFill>
-                  <a:srgbClr val="C05200"/>
-                </a:solidFill>
-                <a:latin typeface="Calibri"/>
-              </a:rPr>
-              <a:t>Recompile spikes remain: forward 15–20 s on new MoE token-count shapes — FWD-only (backward is stable).</a:t>
+                  <a:srgbClr val="1B8A4E"/>
+                </a:solidFill>
+                <a:latin typeface="Calibri"/>
+              </a:rPr>
+              <a:t>Two levers → ~3× (5.8 h → ~2 h/epoch): fixed-shape MoE padding (recompiles) + save once/epoch (checkpoints).</a:t>
             </a:r>
           </a:p>
           <a:p>
@@ -8753,43 +8999,18 @@
             <a:r>
               <a:rPr sz="1600" b="0" i="0">
                 <a:solidFill>
-                  <a:srgbClr val="C05200"/>
-                </a:solidFill>
-                <a:latin typeface="Calibri"/>
-              </a:rPr>
-              <a:t>In bursts these spikes dominate wall-clock (measured ~80% in one window) — the #1 throughput lever.</a:t>
-            </a:r>
-          </a:p>
-          <a:p>
-            <a:pPr>
-              <a:spcAft>
-                <a:spcPts val="600"/>
-              </a:spcAft>
-            </a:pPr>
-            <a:r>
-              <a:rPr sz="1600" b="1" i="0">
-                <a:solidFill>
-                  <a:srgbClr val="2E6CF6"/>
-                </a:solidFill>
-                <a:latin typeface="Calibri"/>
-              </a:rPr>
-              <a:t>•  </a:t>
-            </a:r>
-            <a:r>
-              <a:rPr sz="1600" b="0" i="0">
-                <a:solidFill>
-                  <a:srgbClr val="1B8A4E"/>
-                </a:solidFill>
-                <a:latin typeface="Calibri"/>
-              </a:rPr>
-              <a:t>Fix: fixed-shape MoE padding (pad per-expert counts to buckets → static grouped-GEMM shapes → no recompile).</a:t>
-            </a:r>
-          </a:p>
-        </p:txBody>
-      </p:sp>
-      <p:sp>
-        <p:nvSpPr>
-          <p:cNvPr id="6" name="TextBox 5"/>
+                  <a:srgbClr val="1B2538"/>
+                </a:solidFill>
+                <a:latin typeface="Calibri"/>
+              </a:rPr>
+              <a:t>Backward (~620 ms) dominates the steady step; HS fetch (~27 ms) is NOT the bottleneck (giant 'fetch' spikes were checkpoints).</a:t>
+            </a:r>
+          </a:p>
+        </p:txBody>
+      </p:sp>
+      <p:sp>
+        <p:nvSpPr>
+          <p:cNvPr id="8" name="TextBox 7"/>
           <p:cNvSpPr txBox="1"/>
           <p:nvPr/>
         </p:nvSpPr>

</xml_diff>

<commit_message>
report: name the HS-dumper PR explicitly (#11571 rides; #11196 is the separate inference runtime)
Slide 5 said 'PR-based dumper' but buried the number. Now: the dumper rides vllm-ascend PR #11571
(the DSV4 forward's _dspark_hidden_buffer, gated on dspark_target_layer_ids); the hook is our
feat/dsv4-hs-dumper fork branch; and a note that #11196 (inference runtime) is a DIFFERENT PR, so
readers don't conflate the two.
</commit_message>
<xml_diff>
--- a/docs/reports/dsv4_dspark_npu_report.pptx
+++ b/docs/reports/dsv4_dspark_npu_report.pptx
@@ -6587,7 +6587,7 @@
                 </a:solidFill>
                 <a:latin typeface="Calibri"/>
               </a:rPr>
-              <a:t>Chosen: Plan-B dumper — rides the DSV4 model's existing target-hidden buffer (vllm-ascend #11571).</a:t>
+              <a:t>Chosen: Plan-B dumper — rides vllm-ascend PR #11571 (the DSV4 forward already fills a target-hidden</a:t>
             </a:r>
           </a:p>
           <a:p>
@@ -6608,11 +6608,11 @@
             <a:r>
               <a:rPr sz="1500" b="0" i="0">
                 <a:solidFill>
-                  <a:srgbClr val="1B2538"/>
-                </a:solidFill>
-                <a:latin typeface="Calibri"/>
-              </a:rPr>
-              <a:t>A runner post-forward hook copies the buffer + post-norm hidden to CPU; writes the standard ArrowDataset format.</a:t>
+                  <a:srgbClr val="1B8A4E"/>
+                </a:solidFill>
+                <a:latin typeface="Calibri"/>
+              </a:rPr>
+              <a:t>buffer _dspark_hidden_buffer at [40,41,42], gated on dspark_target_layer_ids → a plain serve produces HS, no draft ckpt).</a:t>
             </a:r>
           </a:p>
           <a:p>
@@ -6633,11 +6633,61 @@
             <a:r>
               <a:rPr sz="1500" b="0" i="0">
                 <a:solidFill>
+                  <a:srgbClr val="1B2538"/>
+                </a:solidFill>
+                <a:latin typeface="Calibri"/>
+              </a:rPr>
+              <a:t>Our hook (fork branch feat/dsv4-hs-dumper) copies that buffer + post-norm hidden to CPU → standard ArrowDataset format.</a:t>
+            </a:r>
+          </a:p>
+          <a:p>
+            <a:pPr lvl="1">
+              <a:spcAft>
+                <a:spcPts val="600"/>
+              </a:spcAft>
+            </a:pPr>
+            <a:r>
+              <a:rPr sz="1600" b="1" i="0">
+                <a:solidFill>
+                  <a:srgbClr val="5A6678"/>
+                </a:solidFill>
+                <a:latin typeface="Calibri"/>
+              </a:rPr>
+              <a:t>–  </a:t>
+            </a:r>
+            <a:r>
+              <a:rPr sz="1500" b="0" i="0">
+                <a:solidFill>
                   <a:srgbClr val="1B8A4E"/>
                 </a:solidFill>
                 <a:latin typeface="Calibri"/>
               </a:rPr>
               <a:t>Zero extra NPU KV, runs on the validated 0.23.0 serve, no PD-disagg. Validated end-to-end (3436 tok/s).</a:t>
+            </a:r>
+          </a:p>
+          <a:p>
+            <a:pPr lvl="1">
+              <a:spcAft>
+                <a:spcPts val="600"/>
+              </a:spcAft>
+            </a:pPr>
+            <a:r>
+              <a:rPr sz="1600" b="1" i="0">
+                <a:solidFill>
+                  <a:srgbClr val="5A6678"/>
+                </a:solidFill>
+                <a:latin typeface="Calibri"/>
+              </a:rPr>
+              <a:t>–  </a:t>
+            </a:r>
+            <a:r>
+              <a:rPr sz="1500" b="0" i="0">
+                <a:solidFill>
+                  <a:srgbClr val="5A6678"/>
+                </a:solidFill>
+                <a:latin typeface="Calibri"/>
+              </a:rPr>
+              <a:t>(NB: #11571 = the buffer the dumper rides; the separate inference runtime is PR #11196 — don't conflate.)</a:t>
             </a:r>
           </a:p>
         </p:txBody>

</xml_diff>

<commit_message>
report: add full-dataset cost extrapolation slide (Open-PerfectBlend)
New slide 10: extrapolate the current subset run (4416 steps/epoch, 5.8h) to the full
Open-PerfectBlend (~1.3M samples, 10 epochs, ~12x): ~29 days now / ~10-11 days with padding +
save-1x/epoch / ~7 days pure-steady lower bound. Conclusion: HF-native FSDP full run = weeks
(validates method+memory, not full-scale throughput) -> MindSpeed-EP is the production path.
Footers renumbered (now 14 slides).
</commit_message>
<xml_diff>
--- a/docs/reports/dsv4_dspark_npu_report.pptx
+++ b/docs/reports/dsv4_dspark_npu_report.pptx
@@ -18,6 +18,7 @@
     <p:sldId id="266" r:id="rId17"/>
     <p:sldId id="267" r:id="rId18"/>
     <p:sldId id="268" r:id="rId19"/>
+    <p:sldId id="269" r:id="rId20"/>
   </p:sldIdLst>
   <p:sldSz cx="12191695" cy="6858000" type="screen4x3"/>
   <p:notesSz cx="6858000" cy="9144000"/>
@@ -3278,7 +3279,7 @@
                 </a:solidFill>
                 <a:latin typeface="Calibri"/>
               </a:rPr>
-              <a:t>KERNEL</a:t>
+              <a:t>SCALING</a:t>
             </a:r>
           </a:p>
           <a:p>
@@ -3289,22 +3290,96 @@
                 </a:solidFill>
                 <a:latin typeface="Calibri"/>
               </a:rPr>
-              <a:t>Draft attention op — SWA + non-causal + sink</a:t>
+              <a:t>Full-dataset cost extrapolation — Open-PerfectBlend</a:t>
+            </a:r>
+          </a:p>
+        </p:txBody>
+      </p:sp>
+      <p:sp>
+        <p:nvSpPr>
+          <p:cNvPr id="4" name="TextBox 3"/>
+          <p:cNvSpPr txBox="1"/>
+          <p:nvPr/>
+        </p:nvSpPr>
+        <p:spPr>
+          <a:xfrm>
+            <a:off x="548640" y="1280160"/>
+            <a:ext cx="11064240" cy="5120640"/>
+          </a:xfrm>
+          <a:prstGeom prst="rect">
+            <a:avLst/>
+          </a:prstGeom>
+          <a:noFill/>
+        </p:spPr>
+        <p:txBody>
+          <a:bodyPr wrap="square">
+            <a:spAutoFit/>
+          </a:bodyPr>
+          <a:lstStyle/>
+          <a:p/>
+          <a:p>
+            <a:pPr>
+              <a:spcAft>
+                <a:spcPts val="600"/>
+              </a:spcAft>
+            </a:pPr>
+            <a:r>
+              <a:rPr sz="1600" b="1" i="0">
+                <a:solidFill>
+                  <a:srgbClr val="2E6CF6"/>
+                </a:solidFill>
+                <a:latin typeface="Calibri"/>
+              </a:rPr>
+              <a:t>•  </a:t>
+            </a:r>
+            <a:r>
+              <a:rPr sz="1600" b="0" i="0">
+                <a:solidFill>
+                  <a:srgbClr val="1B2538"/>
+                </a:solidFill>
+                <a:latin typeface="Calibri"/>
+              </a:rPr>
+              <a:t>Current run: 4416 steps/epoch, 5.8 h/epoch (effective), ≈108 M tokens ≈ ~100k samples — a SUBSET.</a:t>
+            </a:r>
+          </a:p>
+          <a:p>
+            <a:pPr>
+              <a:spcAft>
+                <a:spcPts val="600"/>
+              </a:spcAft>
+            </a:pPr>
+            <a:r>
+              <a:rPr sz="1600" b="1" i="0">
+                <a:solidFill>
+                  <a:srgbClr val="2E6CF6"/>
+                </a:solidFill>
+                <a:latin typeface="Calibri"/>
+              </a:rPr>
+              <a:t>•  </a:t>
+            </a:r>
+            <a:r>
+              <a:rPr sz="1600" b="0" i="0">
+                <a:solidFill>
+                  <a:srgbClr val="1B2538"/>
+                </a:solidFill>
+                <a:latin typeface="Calibri"/>
+              </a:rPr>
+              <a:t>Full Open-PerfectBlend ≈ 1.3 M samples, 10 epochs (paper) ≈ ~12× the current dataset.</a:t>
             </a:r>
           </a:p>
         </p:txBody>
       </p:sp>
       <p:graphicFrame>
         <p:nvGraphicFramePr>
-          <p:cNvPr id="4" name="Table 3"/>
+          <p:cNvPr id="5" name="Table 4"/>
           <p:cNvGraphicFramePr>
             <a:graphicFrameLocks noGrp="1"/>
           </p:cNvGraphicFramePr>
           <p:nvPr/>
         </p:nvGraphicFramePr>
         <p:xfrm>
-          <a:off x="548640" y="1417320"/>
-          <a:ext cx="11521440" cy="1828800"/>
+          <a:off x="548640" y="2468880"/>
+          <a:ext cx="11064240" cy="1463040"/>
         </p:xfrm>
         <a:graphic>
           <a:graphicData uri="http://schemas.openxmlformats.org/drawingml/2006/table">
@@ -3313,12 +3388,9 @@
                 <a:tableStyleId>{5C22544A-7EE6-4342-B048-85BDC9FD1C3A}</a:tableStyleId>
               </a:tblPr>
               <a:tblGrid>
-                <a:gridCol w="3840480"/>
-                <a:gridCol w="1005840"/>
-                <a:gridCol w="1554480"/>
-                <a:gridCol w="1005840"/>
-                <a:gridCol w="1371600"/>
-                <a:gridCol w="2743200"/>
+                <a:gridCol w="5212080"/>
+                <a:gridCol w="3017520"/>
+                <a:gridCol w="2834640"/>
               </a:tblGrid>
               <a:tr h="365760">
                 <a:tc>
@@ -3327,13 +3399,13 @@
                     <a:lstStyle/>
                     <a:p>
                       <a:r>
-                        <a:rPr sz="1200" b="1" i="0">
+                        <a:rPr sz="1300" b="1" i="0">
                           <a:solidFill>
                             <a:srgbClr val="FFFFFF"/>
                           </a:solidFill>
                           <a:latin typeface="Calibri"/>
                         </a:rPr>
-                        <a:t>op</a:t>
+                        <a:t>scenario</a:t>
                       </a:r>
                     </a:p>
                   </a:txBody>
@@ -3349,13 +3421,13 @@
                     <a:lstStyle/>
                     <a:p>
                       <a:r>
-                        <a:rPr sz="1200" b="1" i="0">
+                        <a:rPr sz="1300" b="1" i="0">
                           <a:solidFill>
                             <a:srgbClr val="FFFFFF"/>
                           </a:solidFill>
                           <a:latin typeface="Calibri"/>
                         </a:rPr>
-                        <a:t>SWA</a:t>
+                        <a:t>per full-epoch (~12×)</a:t>
                       </a:r>
                     </a:p>
                   </a:txBody>
@@ -3371,79 +3443,13 @@
                     <a:lstStyle/>
                     <a:p>
                       <a:r>
-                        <a:rPr sz="1200" b="1" i="0">
+                        <a:rPr sz="1300" b="1" i="0">
                           <a:solidFill>
                             <a:srgbClr val="FFFFFF"/>
                           </a:solidFill>
                           <a:latin typeface="Calibri"/>
                         </a:rPr>
-                        <a:t>non-causal</a:t>
-                      </a:r>
-                    </a:p>
-                  </a:txBody>
-                  <a:tcPr>
-                    <a:solidFill>
-                      <a:srgbClr val="1B2538"/>
-                    </a:solidFill>
-                  </a:tcPr>
-                </a:tc>
-                <a:tc>
-                  <a:txBody>
-                    <a:bodyPr/>
-                    <a:lstStyle/>
-                    <a:p>
-                      <a:r>
-                        <a:rPr sz="1200" b="1" i="0">
-                          <a:solidFill>
-                            <a:srgbClr val="FFFFFF"/>
-                          </a:solidFill>
-                          <a:latin typeface="Calibri"/>
-                        </a:rPr>
-                        <a:t>sink</a:t>
-                      </a:r>
-                    </a:p>
-                  </a:txBody>
-                  <a:tcPr>
-                    <a:solidFill>
-                      <a:srgbClr val="1B2538"/>
-                    </a:solidFill>
-                  </a:tcPr>
-                </a:tc>
-                <a:tc>
-                  <a:txBody>
-                    <a:bodyPr/>
-                    <a:lstStyle/>
-                    <a:p>
-                      <a:r>
-                        <a:rPr sz="1200" b="1" i="0">
-                          <a:solidFill>
-                            <a:srgbClr val="FFFFFF"/>
-                          </a:solidFill>
-                          <a:latin typeface="Calibri"/>
-                        </a:rPr>
-                        <a:t>backward</a:t>
-                      </a:r>
-                    </a:p>
-                  </a:txBody>
-                  <a:tcPr>
-                    <a:solidFill>
-                      <a:srgbClr val="1B2538"/>
-                    </a:solidFill>
-                  </a:tcPr>
-                </a:tc>
-                <a:tc>
-                  <a:txBody>
-                    <a:bodyPr/>
-                    <a:lstStyle/>
-                    <a:p>
-                      <a:r>
-                        <a:rPr sz="1200" b="1" i="0">
-                          <a:solidFill>
-                            <a:srgbClr val="FFFFFF"/>
-                          </a:solidFill>
-                          <a:latin typeface="Calibri"/>
-                        </a:rPr>
-                        <a:t>use</a:t>
+                        <a:t>× 10 epochs (paper)</a:t>
                       </a:r>
                     </a:p>
                   </a:txBody>
@@ -3461,13 +3467,13 @@
                     <a:lstStyle/>
                     <a:p>
                       <a:r>
-                        <a:rPr sz="1200" b="0" i="0">
+                        <a:rPr sz="1300" b="0" i="0">
                           <a:solidFill>
                             <a:srgbClr val="1B2538"/>
                           </a:solidFill>
                           <a:latin typeface="Calibri"/>
                         </a:rPr>
-                        <a:t>vllm-ascend SAS (inference)</a:t>
+                        <a:t>current (recompile + checkpoint spikes)</a:t>
                       </a:r>
                     </a:p>
                   </a:txBody>
@@ -3483,13 +3489,13 @@
                     <a:lstStyle/>
                     <a:p>
                       <a:r>
-                        <a:rPr sz="1200" b="0" i="0">
+                        <a:rPr sz="1300" b="0" i="0">
                           <a:solidFill>
                             <a:srgbClr val="1B2538"/>
                           </a:solidFill>
                           <a:latin typeface="Calibri"/>
                         </a:rPr>
-                        <a:t>✓</a:t>
+                        <a:t>~70 h</a:t>
                       </a:r>
                     </a:p>
                   </a:txBody>
@@ -3505,79 +3511,13 @@
                     <a:lstStyle/>
                     <a:p>
                       <a:r>
-                        <a:rPr sz="1200" b="0" i="0">
+                        <a:rPr sz="1300" b="0" i="0">
                           <a:solidFill>
                             <a:srgbClr val="1B2538"/>
                           </a:solidFill>
                           <a:latin typeface="Calibri"/>
                         </a:rPr>
-                        <a:t>✓</a:t>
-                      </a:r>
-                    </a:p>
-                  </a:txBody>
-                  <a:tcPr>
-                    <a:solidFill>
-                      <a:srgbClr val="F5F7FA"/>
-                    </a:solidFill>
-                  </a:tcPr>
-                </a:tc>
-                <a:tc>
-                  <a:txBody>
-                    <a:bodyPr/>
-                    <a:lstStyle/>
-                    <a:p>
-                      <a:r>
-                        <a:rPr sz="1200" b="0" i="0">
-                          <a:solidFill>
-                            <a:srgbClr val="1B2538"/>
-                          </a:solidFill>
-                          <a:latin typeface="Calibri"/>
-                        </a:rPr>
-                        <a:t>✓</a:t>
-                      </a:r>
-                    </a:p>
-                  </a:txBody>
-                  <a:tcPr>
-                    <a:solidFill>
-                      <a:srgbClr val="F5F7FA"/>
-                    </a:solidFill>
-                  </a:tcPr>
-                </a:tc>
-                <a:tc>
-                  <a:txBody>
-                    <a:bodyPr/>
-                    <a:lstStyle/>
-                    <a:p>
-                      <a:r>
-                        <a:rPr sz="1200" b="0" i="0">
-                          <a:solidFill>
-                            <a:srgbClr val="1B2538"/>
-                          </a:solidFill>
-                          <a:latin typeface="Calibri"/>
-                        </a:rPr>
-                        <a:t>✗</a:t>
-                      </a:r>
-                    </a:p>
-                  </a:txBody>
-                  <a:tcPr>
-                    <a:solidFill>
-                      <a:srgbClr val="F5F7FA"/>
-                    </a:solidFill>
-                  </a:tcPr>
-                </a:tc>
-                <a:tc>
-                  <a:txBody>
-                    <a:bodyPr/>
-                    <a:lstStyle/>
-                    <a:p>
-                      <a:r>
-                        <a:rPr sz="1200" b="0" i="0">
-                          <a:solidFill>
-                            <a:srgbClr val="1B2538"/>
-                          </a:solidFill>
-                          <a:latin typeface="Calibri"/>
-                        </a:rPr>
-                        <a:t>inference / gold reference</a:t>
+                        <a:t>~29 days</a:t>
                       </a:r>
                     </a:p>
                   </a:txBody>
@@ -3595,13 +3535,13 @@
                     <a:lstStyle/>
                     <a:p>
                       <a:r>
-                        <a:rPr sz="1200" b="0" i="0">
+                        <a:rPr sz="1300" b="0" i="0">
                           <a:solidFill>
                             <a:srgbClr val="1B2538"/>
                           </a:solidFill>
                           <a:latin typeface="Calibri"/>
                         </a:rPr>
-                        <a:t>SDPA / npu_fusion_attention</a:t>
+                        <a:t>+ fixed-shape MoE padding + save 1×/epoch</a:t>
                       </a:r>
                     </a:p>
                   </a:txBody>
@@ -3617,13 +3557,13 @@
                     <a:lstStyle/>
                     <a:p>
                       <a:r>
-                        <a:rPr sz="1200" b="0" i="0">
+                        <a:rPr sz="1300" b="0" i="0">
                           <a:solidFill>
                             <a:srgbClr val="1B2538"/>
                           </a:solidFill>
                           <a:latin typeface="Calibri"/>
                         </a:rPr>
-                        <a:t>✓</a:t>
+                        <a:t>~25 h</a:t>
                       </a:r>
                     </a:p>
                   </a:txBody>
@@ -3639,79 +3579,13 @@
                     <a:lstStyle/>
                     <a:p>
                       <a:r>
-                        <a:rPr sz="1200" b="0" i="0">
+                        <a:rPr sz="1300" b="0" i="0">
                           <a:solidFill>
                             <a:srgbClr val="1B2538"/>
                           </a:solidFill>
                           <a:latin typeface="Calibri"/>
                         </a:rPr>
-                        <a:t>✗</a:t>
-                      </a:r>
-                    </a:p>
-                  </a:txBody>
-                  <a:tcPr>
-                    <a:solidFill>
-                      <a:srgbClr val="FFFFFF"/>
-                    </a:solidFill>
-                  </a:tcPr>
-                </a:tc>
-                <a:tc>
-                  <a:txBody>
-                    <a:bodyPr/>
-                    <a:lstStyle/>
-                    <a:p>
-                      <a:r>
-                        <a:rPr sz="1200" b="0" i="0">
-                          <a:solidFill>
-                            <a:srgbClr val="1B2538"/>
-                          </a:solidFill>
-                          <a:latin typeface="Calibri"/>
-                        </a:rPr>
-                        <a:t>✗</a:t>
-                      </a:r>
-                    </a:p>
-                  </a:txBody>
-                  <a:tcPr>
-                    <a:solidFill>
-                      <a:srgbClr val="FFFFFF"/>
-                    </a:solidFill>
-                  </a:tcPr>
-                </a:tc>
-                <a:tc>
-                  <a:txBody>
-                    <a:bodyPr/>
-                    <a:lstStyle/>
-                    <a:p>
-                      <a:r>
-                        <a:rPr sz="1200" b="0" i="0">
-                          <a:solidFill>
-                            <a:srgbClr val="1B2538"/>
-                          </a:solidFill>
-                          <a:latin typeface="Calibri"/>
-                        </a:rPr>
-                        <a:t>✓</a:t>
-                      </a:r>
-                    </a:p>
-                  </a:txBody>
-                  <a:tcPr>
-                    <a:solidFill>
-                      <a:srgbClr val="FFFFFF"/>
-                    </a:solidFill>
-                  </a:tcPr>
-                </a:tc>
-                <a:tc>
-                  <a:txBody>
-                    <a:bodyPr/>
-                    <a:lstStyle/>
-                    <a:p>
-                      <a:r>
-                        <a:rPr sz="1200" b="0" i="0">
-                          <a:solidFill>
-                            <a:srgbClr val="1B2538"/>
-                          </a:solidFill>
-                          <a:latin typeface="Calibri"/>
-                        </a:rPr>
-                        <a:t>— (missing sink + non-causal)</a:t>
+                        <a:t>~10–11 days</a:t>
                       </a:r>
                     </a:p>
                   </a:txBody>
@@ -3729,13 +3603,13 @@
                     <a:lstStyle/>
                     <a:p>
                       <a:r>
-                        <a:rPr sz="1200" b="0" i="0">
+                        <a:rPr sz="1300" b="0" i="0">
                           <a:solidFill>
                             <a:srgbClr val="1B2538"/>
                           </a:solidFill>
                           <a:latin typeface="Calibri"/>
                         </a:rPr>
-                        <a:t>einsum (current training path)</a:t>
+                        <a:t>pure steady (spikes eliminated — lower bound)</a:t>
                       </a:r>
                     </a:p>
                   </a:txBody>
@@ -3751,13 +3625,13 @@
                     <a:lstStyle/>
                     <a:p>
                       <a:r>
-                        <a:rPr sz="1200" b="0" i="0">
+                        <a:rPr sz="1300" b="0" i="0">
                           <a:solidFill>
                             <a:srgbClr val="1B2538"/>
                           </a:solidFill>
                           <a:latin typeface="Calibri"/>
                         </a:rPr>
-                        <a:t>✓</a:t>
+                        <a:t>~17 h</a:t>
                       </a:r>
                     </a:p>
                   </a:txBody>
@@ -3773,219 +3647,19 @@
                     <a:lstStyle/>
                     <a:p>
                       <a:r>
-                        <a:rPr sz="1200" b="0" i="0">
+                        <a:rPr sz="1300" b="0" i="0">
                           <a:solidFill>
                             <a:srgbClr val="1B2538"/>
                           </a:solidFill>
                           <a:latin typeface="Calibri"/>
                         </a:rPr>
-                        <a:t>✓</a:t>
+                        <a:t>~7 days</a:t>
                       </a:r>
                     </a:p>
                   </a:txBody>
                   <a:tcPr>
                     <a:solidFill>
                       <a:srgbClr val="F5F7FA"/>
-                    </a:solidFill>
-                  </a:tcPr>
-                </a:tc>
-                <a:tc>
-                  <a:txBody>
-                    <a:bodyPr/>
-                    <a:lstStyle/>
-                    <a:p>
-                      <a:r>
-                        <a:rPr sz="1200" b="0" i="0">
-                          <a:solidFill>
-                            <a:srgbClr val="1B2538"/>
-                          </a:solidFill>
-                          <a:latin typeface="Calibri"/>
-                        </a:rPr>
-                        <a:t>✓</a:t>
-                      </a:r>
-                    </a:p>
-                  </a:txBody>
-                  <a:tcPr>
-                    <a:solidFill>
-                      <a:srgbClr val="F5F7FA"/>
-                    </a:solidFill>
-                  </a:tcPr>
-                </a:tc>
-                <a:tc>
-                  <a:txBody>
-                    <a:bodyPr/>
-                    <a:lstStyle/>
-                    <a:p>
-                      <a:r>
-                        <a:rPr sz="1200" b="0" i="0">
-                          <a:solidFill>
-                            <a:srgbClr val="1B2538"/>
-                          </a:solidFill>
-                          <a:latin typeface="Calibri"/>
-                        </a:rPr>
-                        <a:t>✓ slow</a:t>
-                      </a:r>
-                    </a:p>
-                  </a:txBody>
-                  <a:tcPr>
-                    <a:solidFill>
-                      <a:srgbClr val="F5F7FA"/>
-                    </a:solidFill>
-                  </a:tcPr>
-                </a:tc>
-                <a:tc>
-                  <a:txBody>
-                    <a:bodyPr/>
-                    <a:lstStyle/>
-                    <a:p>
-                      <a:r>
-                        <a:rPr sz="1200" b="0" i="0">
-                          <a:solidFill>
-                            <a:srgbClr val="1B2538"/>
-                          </a:solidFill>
-                          <a:latin typeface="Calibri"/>
-                        </a:rPr>
-                        <a:t>training now</a:t>
-                      </a:r>
-                    </a:p>
-                  </a:txBody>
-                  <a:tcPr>
-                    <a:solidFill>
-                      <a:srgbClr val="F5F7FA"/>
-                    </a:solidFill>
-                  </a:tcPr>
-                </a:tc>
-              </a:tr>
-              <a:tr h="365760">
-                <a:tc>
-                  <a:txBody>
-                    <a:bodyPr/>
-                    <a:lstStyle/>
-                    <a:p>
-                      <a:r>
-                        <a:rPr sz="1200" b="0" i="0">
-                          <a:solidFill>
-                            <a:srgbClr val="1B2538"/>
-                          </a:solidFill>
-                          <a:latin typeface="Calibri"/>
-                        </a:rPr>
-                        <a:t>Triton kernel (built)</a:t>
-                      </a:r>
-                    </a:p>
-                  </a:txBody>
-                  <a:tcPr>
-                    <a:solidFill>
-                      <a:srgbClr val="FFFFFF"/>
-                    </a:solidFill>
-                  </a:tcPr>
-                </a:tc>
-                <a:tc>
-                  <a:txBody>
-                    <a:bodyPr/>
-                    <a:lstStyle/>
-                    <a:p>
-                      <a:r>
-                        <a:rPr sz="1200" b="0" i="0">
-                          <a:solidFill>
-                            <a:srgbClr val="1B2538"/>
-                          </a:solidFill>
-                          <a:latin typeface="Calibri"/>
-                        </a:rPr>
-                        <a:t>✓</a:t>
-                      </a:r>
-                    </a:p>
-                  </a:txBody>
-                  <a:tcPr>
-                    <a:solidFill>
-                      <a:srgbClr val="FFFFFF"/>
-                    </a:solidFill>
-                  </a:tcPr>
-                </a:tc>
-                <a:tc>
-                  <a:txBody>
-                    <a:bodyPr/>
-                    <a:lstStyle/>
-                    <a:p>
-                      <a:r>
-                        <a:rPr sz="1200" b="0" i="0">
-                          <a:solidFill>
-                            <a:srgbClr val="1B2538"/>
-                          </a:solidFill>
-                          <a:latin typeface="Calibri"/>
-                        </a:rPr>
-                        <a:t>✓</a:t>
-                      </a:r>
-                    </a:p>
-                  </a:txBody>
-                  <a:tcPr>
-                    <a:solidFill>
-                      <a:srgbClr val="FFFFFF"/>
-                    </a:solidFill>
-                  </a:tcPr>
-                </a:tc>
-                <a:tc>
-                  <a:txBody>
-                    <a:bodyPr/>
-                    <a:lstStyle/>
-                    <a:p>
-                      <a:r>
-                        <a:rPr sz="1200" b="0" i="0">
-                          <a:solidFill>
-                            <a:srgbClr val="1B2538"/>
-                          </a:solidFill>
-                          <a:latin typeface="Calibri"/>
-                        </a:rPr>
-                        <a:t>✓</a:t>
-                      </a:r>
-                    </a:p>
-                  </a:txBody>
-                  <a:tcPr>
-                    <a:solidFill>
-                      <a:srgbClr val="FFFFFF"/>
-                    </a:solidFill>
-                  </a:tcPr>
-                </a:tc>
-                <a:tc>
-                  <a:txBody>
-                    <a:bodyPr/>
-                    <a:lstStyle/>
-                    <a:p>
-                      <a:r>
-                        <a:rPr sz="1200" b="0" i="0">
-                          <a:solidFill>
-                            <a:srgbClr val="1B2538"/>
-                          </a:solidFill>
-                          <a:latin typeface="Calibri"/>
-                        </a:rPr>
-                        <a:t>✓</a:t>
-                      </a:r>
-                    </a:p>
-                  </a:txBody>
-                  <a:tcPr>
-                    <a:solidFill>
-                      <a:srgbClr val="FFFFFF"/>
-                    </a:solidFill>
-                  </a:tcPr>
-                </a:tc>
-                <a:tc>
-                  <a:txBody>
-                    <a:bodyPr/>
-                    <a:lstStyle/>
-                    <a:p>
-                      <a:r>
-                        <a:rPr sz="1200" b="0" i="0">
-                          <a:solidFill>
-                            <a:srgbClr val="1B2538"/>
-                          </a:solidFill>
-                          <a:latin typeface="Calibri"/>
-                        </a:rPr>
-                        <a:t>training target — 5.96e-7 vs gold</a:t>
-                      </a:r>
-                    </a:p>
-                  </a:txBody>
-                  <a:tcPr>
-                    <a:solidFill>
-                      <a:srgbClr val="FFFFFF"/>
                     </a:solidFill>
                   </a:tcPr>
                 </a:tc>
@@ -3996,13 +3670,13 @@
       </p:graphicFrame>
       <p:sp>
         <p:nvSpPr>
-          <p:cNvPr id="5" name="TextBox 4"/>
+          <p:cNvPr id="6" name="TextBox 5"/>
           <p:cNvSpPr txBox="1"/>
           <p:nvPr/>
         </p:nvSpPr>
         <p:spPr>
           <a:xfrm>
-            <a:off x="548640" y="4114800"/>
+            <a:off x="548640" y="4160520"/>
             <a:ext cx="11064240" cy="5120640"/>
           </a:xfrm>
           <a:prstGeom prst="rect">
@@ -4034,11 +3708,11 @@
             <a:r>
               <a:rPr sz="1600" b="0" i="0">
                 <a:solidFill>
-                  <a:srgbClr val="1B2538"/>
-                </a:solidFill>
-                <a:latin typeface="Calibri"/>
-              </a:rPr>
-              <a:t>No single fused op has all four — so training uses the (correct but slow) einsum; the Triton kernel fuses it.</a:t>
+                  <a:srgbClr val="C05200"/>
+                </a:solidFill>
+                <a:latin typeface="Calibri"/>
+              </a:rPr>
+              <a:t>HF-native FSDP full run = WEEKS → it validates method-correctness + memory, NOT full-scale throughput.</a:t>
             </a:r>
           </a:p>
           <a:p>
@@ -4063,7 +3737,7 @@
                 </a:solidFill>
                 <a:latin typeface="Calibri"/>
               </a:rPr>
-              <a:t>Triton kernel is done and validated (matches the gold reference at fp32 5.96e-7); needs integration into training.</a:t>
+              <a:t>Production-scale plan = MindSpeed-EP (whole expert per card + all-to-all) — removes the 768 per-expert collectives + the spikes.</a:t>
             </a:r>
           </a:p>
           <a:p>
@@ -4084,18 +3758,18 @@
             <a:r>
               <a:rPr sz="1600" b="0" i="0">
                 <a:solidFill>
-                  <a:srgbClr val="1B2538"/>
-                </a:solidFill>
-                <a:latin typeface="Calibri"/>
-              </a:rPr>
-              <a:t>Real inference dispatches to the SAS op (source verified non-causal; #11196 relaxed the causal asserts).</a:t>
-            </a:r>
-          </a:p>
-        </p:txBody>
-      </p:sp>
-      <p:sp>
-        <p:nvSpPr>
-          <p:cNvPr id="6" name="TextBox 5"/>
+                  <a:srgbClr val="2E6CF6"/>
+                </a:solidFill>
+                <a:latin typeface="Calibri"/>
+              </a:rPr>
+              <a:t>Practical path: train the subset a few more epochs to prove the method (accept_len → ~3.9), then MindSpeed-EP for full scale.</a:t>
+            </a:r>
+          </a:p>
+        </p:txBody>
+      </p:sp>
+      <p:sp>
+        <p:nvSpPr>
+          <p:cNvPr id="7" name="TextBox 6"/>
           <p:cNvSpPr txBox="1"/>
           <p:nvPr/>
         </p:nvSpPr>
@@ -4226,7 +3900,7 @@
                 </a:solidFill>
                 <a:latin typeface="Calibri"/>
               </a:rPr>
-              <a:t>VALIDATION</a:t>
+              <a:t>KERNEL</a:t>
             </a:r>
           </a:p>
           <a:p>
@@ -4237,20 +3911,720 @@
                 </a:solidFill>
                 <a:latin typeface="Calibri"/>
               </a:rPr>
-              <a:t>Correctness validation — "it runs" ≠ "it's correct"</a:t>
-            </a:r>
-          </a:p>
-        </p:txBody>
-      </p:sp>
-      <p:sp>
-        <p:nvSpPr>
-          <p:cNvPr id="4" name="TextBox 3"/>
+              <a:t>Draft attention op — SWA + non-causal + sink</a:t>
+            </a:r>
+          </a:p>
+        </p:txBody>
+      </p:sp>
+      <p:graphicFrame>
+        <p:nvGraphicFramePr>
+          <p:cNvPr id="4" name="Table 3"/>
+          <p:cNvGraphicFramePr>
+            <a:graphicFrameLocks noGrp="1"/>
+          </p:cNvGraphicFramePr>
+          <p:nvPr/>
+        </p:nvGraphicFramePr>
+        <p:xfrm>
+          <a:off x="548640" y="1417320"/>
+          <a:ext cx="11521440" cy="1828800"/>
+        </p:xfrm>
+        <a:graphic>
+          <a:graphicData uri="http://schemas.openxmlformats.org/drawingml/2006/table">
+            <a:tbl>
+              <a:tblPr firstRow="1" bandRow="1">
+                <a:tableStyleId>{5C22544A-7EE6-4342-B048-85BDC9FD1C3A}</a:tableStyleId>
+              </a:tblPr>
+              <a:tblGrid>
+                <a:gridCol w="3840480"/>
+                <a:gridCol w="1005840"/>
+                <a:gridCol w="1554480"/>
+                <a:gridCol w="1005840"/>
+                <a:gridCol w="1371600"/>
+                <a:gridCol w="2743200"/>
+              </a:tblGrid>
+              <a:tr h="365760">
+                <a:tc>
+                  <a:txBody>
+                    <a:bodyPr/>
+                    <a:lstStyle/>
+                    <a:p>
+                      <a:r>
+                        <a:rPr sz="1200" b="1" i="0">
+                          <a:solidFill>
+                            <a:srgbClr val="FFFFFF"/>
+                          </a:solidFill>
+                          <a:latin typeface="Calibri"/>
+                        </a:rPr>
+                        <a:t>op</a:t>
+                      </a:r>
+                    </a:p>
+                  </a:txBody>
+                  <a:tcPr>
+                    <a:solidFill>
+                      <a:srgbClr val="1B2538"/>
+                    </a:solidFill>
+                  </a:tcPr>
+                </a:tc>
+                <a:tc>
+                  <a:txBody>
+                    <a:bodyPr/>
+                    <a:lstStyle/>
+                    <a:p>
+                      <a:r>
+                        <a:rPr sz="1200" b="1" i="0">
+                          <a:solidFill>
+                            <a:srgbClr val="FFFFFF"/>
+                          </a:solidFill>
+                          <a:latin typeface="Calibri"/>
+                        </a:rPr>
+                        <a:t>SWA</a:t>
+                      </a:r>
+                    </a:p>
+                  </a:txBody>
+                  <a:tcPr>
+                    <a:solidFill>
+                      <a:srgbClr val="1B2538"/>
+                    </a:solidFill>
+                  </a:tcPr>
+                </a:tc>
+                <a:tc>
+                  <a:txBody>
+                    <a:bodyPr/>
+                    <a:lstStyle/>
+                    <a:p>
+                      <a:r>
+                        <a:rPr sz="1200" b="1" i="0">
+                          <a:solidFill>
+                            <a:srgbClr val="FFFFFF"/>
+                          </a:solidFill>
+                          <a:latin typeface="Calibri"/>
+                        </a:rPr>
+                        <a:t>non-causal</a:t>
+                      </a:r>
+                    </a:p>
+                  </a:txBody>
+                  <a:tcPr>
+                    <a:solidFill>
+                      <a:srgbClr val="1B2538"/>
+                    </a:solidFill>
+                  </a:tcPr>
+                </a:tc>
+                <a:tc>
+                  <a:txBody>
+                    <a:bodyPr/>
+                    <a:lstStyle/>
+                    <a:p>
+                      <a:r>
+                        <a:rPr sz="1200" b="1" i="0">
+                          <a:solidFill>
+                            <a:srgbClr val="FFFFFF"/>
+                          </a:solidFill>
+                          <a:latin typeface="Calibri"/>
+                        </a:rPr>
+                        <a:t>sink</a:t>
+                      </a:r>
+                    </a:p>
+                  </a:txBody>
+                  <a:tcPr>
+                    <a:solidFill>
+                      <a:srgbClr val="1B2538"/>
+                    </a:solidFill>
+                  </a:tcPr>
+                </a:tc>
+                <a:tc>
+                  <a:txBody>
+                    <a:bodyPr/>
+                    <a:lstStyle/>
+                    <a:p>
+                      <a:r>
+                        <a:rPr sz="1200" b="1" i="0">
+                          <a:solidFill>
+                            <a:srgbClr val="FFFFFF"/>
+                          </a:solidFill>
+                          <a:latin typeface="Calibri"/>
+                        </a:rPr>
+                        <a:t>backward</a:t>
+                      </a:r>
+                    </a:p>
+                  </a:txBody>
+                  <a:tcPr>
+                    <a:solidFill>
+                      <a:srgbClr val="1B2538"/>
+                    </a:solidFill>
+                  </a:tcPr>
+                </a:tc>
+                <a:tc>
+                  <a:txBody>
+                    <a:bodyPr/>
+                    <a:lstStyle/>
+                    <a:p>
+                      <a:r>
+                        <a:rPr sz="1200" b="1" i="0">
+                          <a:solidFill>
+                            <a:srgbClr val="FFFFFF"/>
+                          </a:solidFill>
+                          <a:latin typeface="Calibri"/>
+                        </a:rPr>
+                        <a:t>use</a:t>
+                      </a:r>
+                    </a:p>
+                  </a:txBody>
+                  <a:tcPr>
+                    <a:solidFill>
+                      <a:srgbClr val="1B2538"/>
+                    </a:solidFill>
+                  </a:tcPr>
+                </a:tc>
+              </a:tr>
+              <a:tr h="365760">
+                <a:tc>
+                  <a:txBody>
+                    <a:bodyPr/>
+                    <a:lstStyle/>
+                    <a:p>
+                      <a:r>
+                        <a:rPr sz="1200" b="0" i="0">
+                          <a:solidFill>
+                            <a:srgbClr val="1B2538"/>
+                          </a:solidFill>
+                          <a:latin typeface="Calibri"/>
+                        </a:rPr>
+                        <a:t>vllm-ascend SAS (inference)</a:t>
+                      </a:r>
+                    </a:p>
+                  </a:txBody>
+                  <a:tcPr>
+                    <a:solidFill>
+                      <a:srgbClr val="F5F7FA"/>
+                    </a:solidFill>
+                  </a:tcPr>
+                </a:tc>
+                <a:tc>
+                  <a:txBody>
+                    <a:bodyPr/>
+                    <a:lstStyle/>
+                    <a:p>
+                      <a:r>
+                        <a:rPr sz="1200" b="0" i="0">
+                          <a:solidFill>
+                            <a:srgbClr val="1B2538"/>
+                          </a:solidFill>
+                          <a:latin typeface="Calibri"/>
+                        </a:rPr>
+                        <a:t>✓</a:t>
+                      </a:r>
+                    </a:p>
+                  </a:txBody>
+                  <a:tcPr>
+                    <a:solidFill>
+                      <a:srgbClr val="F5F7FA"/>
+                    </a:solidFill>
+                  </a:tcPr>
+                </a:tc>
+                <a:tc>
+                  <a:txBody>
+                    <a:bodyPr/>
+                    <a:lstStyle/>
+                    <a:p>
+                      <a:r>
+                        <a:rPr sz="1200" b="0" i="0">
+                          <a:solidFill>
+                            <a:srgbClr val="1B2538"/>
+                          </a:solidFill>
+                          <a:latin typeface="Calibri"/>
+                        </a:rPr>
+                        <a:t>✓</a:t>
+                      </a:r>
+                    </a:p>
+                  </a:txBody>
+                  <a:tcPr>
+                    <a:solidFill>
+                      <a:srgbClr val="F5F7FA"/>
+                    </a:solidFill>
+                  </a:tcPr>
+                </a:tc>
+                <a:tc>
+                  <a:txBody>
+                    <a:bodyPr/>
+                    <a:lstStyle/>
+                    <a:p>
+                      <a:r>
+                        <a:rPr sz="1200" b="0" i="0">
+                          <a:solidFill>
+                            <a:srgbClr val="1B2538"/>
+                          </a:solidFill>
+                          <a:latin typeface="Calibri"/>
+                        </a:rPr>
+                        <a:t>✓</a:t>
+                      </a:r>
+                    </a:p>
+                  </a:txBody>
+                  <a:tcPr>
+                    <a:solidFill>
+                      <a:srgbClr val="F5F7FA"/>
+                    </a:solidFill>
+                  </a:tcPr>
+                </a:tc>
+                <a:tc>
+                  <a:txBody>
+                    <a:bodyPr/>
+                    <a:lstStyle/>
+                    <a:p>
+                      <a:r>
+                        <a:rPr sz="1200" b="0" i="0">
+                          <a:solidFill>
+                            <a:srgbClr val="1B2538"/>
+                          </a:solidFill>
+                          <a:latin typeface="Calibri"/>
+                        </a:rPr>
+                        <a:t>✗</a:t>
+                      </a:r>
+                    </a:p>
+                  </a:txBody>
+                  <a:tcPr>
+                    <a:solidFill>
+                      <a:srgbClr val="F5F7FA"/>
+                    </a:solidFill>
+                  </a:tcPr>
+                </a:tc>
+                <a:tc>
+                  <a:txBody>
+                    <a:bodyPr/>
+                    <a:lstStyle/>
+                    <a:p>
+                      <a:r>
+                        <a:rPr sz="1200" b="0" i="0">
+                          <a:solidFill>
+                            <a:srgbClr val="1B2538"/>
+                          </a:solidFill>
+                          <a:latin typeface="Calibri"/>
+                        </a:rPr>
+                        <a:t>inference / gold reference</a:t>
+                      </a:r>
+                    </a:p>
+                  </a:txBody>
+                  <a:tcPr>
+                    <a:solidFill>
+                      <a:srgbClr val="F5F7FA"/>
+                    </a:solidFill>
+                  </a:tcPr>
+                </a:tc>
+              </a:tr>
+              <a:tr h="365760">
+                <a:tc>
+                  <a:txBody>
+                    <a:bodyPr/>
+                    <a:lstStyle/>
+                    <a:p>
+                      <a:r>
+                        <a:rPr sz="1200" b="0" i="0">
+                          <a:solidFill>
+                            <a:srgbClr val="1B2538"/>
+                          </a:solidFill>
+                          <a:latin typeface="Calibri"/>
+                        </a:rPr>
+                        <a:t>SDPA / npu_fusion_attention</a:t>
+                      </a:r>
+                    </a:p>
+                  </a:txBody>
+                  <a:tcPr>
+                    <a:solidFill>
+                      <a:srgbClr val="FFFFFF"/>
+                    </a:solidFill>
+                  </a:tcPr>
+                </a:tc>
+                <a:tc>
+                  <a:txBody>
+                    <a:bodyPr/>
+                    <a:lstStyle/>
+                    <a:p>
+                      <a:r>
+                        <a:rPr sz="1200" b="0" i="0">
+                          <a:solidFill>
+                            <a:srgbClr val="1B2538"/>
+                          </a:solidFill>
+                          <a:latin typeface="Calibri"/>
+                        </a:rPr>
+                        <a:t>✓</a:t>
+                      </a:r>
+                    </a:p>
+                  </a:txBody>
+                  <a:tcPr>
+                    <a:solidFill>
+                      <a:srgbClr val="FFFFFF"/>
+                    </a:solidFill>
+                  </a:tcPr>
+                </a:tc>
+                <a:tc>
+                  <a:txBody>
+                    <a:bodyPr/>
+                    <a:lstStyle/>
+                    <a:p>
+                      <a:r>
+                        <a:rPr sz="1200" b="0" i="0">
+                          <a:solidFill>
+                            <a:srgbClr val="1B2538"/>
+                          </a:solidFill>
+                          <a:latin typeface="Calibri"/>
+                        </a:rPr>
+                        <a:t>✗</a:t>
+                      </a:r>
+                    </a:p>
+                  </a:txBody>
+                  <a:tcPr>
+                    <a:solidFill>
+                      <a:srgbClr val="FFFFFF"/>
+                    </a:solidFill>
+                  </a:tcPr>
+                </a:tc>
+                <a:tc>
+                  <a:txBody>
+                    <a:bodyPr/>
+                    <a:lstStyle/>
+                    <a:p>
+                      <a:r>
+                        <a:rPr sz="1200" b="0" i="0">
+                          <a:solidFill>
+                            <a:srgbClr val="1B2538"/>
+                          </a:solidFill>
+                          <a:latin typeface="Calibri"/>
+                        </a:rPr>
+                        <a:t>✗</a:t>
+                      </a:r>
+                    </a:p>
+                  </a:txBody>
+                  <a:tcPr>
+                    <a:solidFill>
+                      <a:srgbClr val="FFFFFF"/>
+                    </a:solidFill>
+                  </a:tcPr>
+                </a:tc>
+                <a:tc>
+                  <a:txBody>
+                    <a:bodyPr/>
+                    <a:lstStyle/>
+                    <a:p>
+                      <a:r>
+                        <a:rPr sz="1200" b="0" i="0">
+                          <a:solidFill>
+                            <a:srgbClr val="1B2538"/>
+                          </a:solidFill>
+                          <a:latin typeface="Calibri"/>
+                        </a:rPr>
+                        <a:t>✓</a:t>
+                      </a:r>
+                    </a:p>
+                  </a:txBody>
+                  <a:tcPr>
+                    <a:solidFill>
+                      <a:srgbClr val="FFFFFF"/>
+                    </a:solidFill>
+                  </a:tcPr>
+                </a:tc>
+                <a:tc>
+                  <a:txBody>
+                    <a:bodyPr/>
+                    <a:lstStyle/>
+                    <a:p>
+                      <a:r>
+                        <a:rPr sz="1200" b="0" i="0">
+                          <a:solidFill>
+                            <a:srgbClr val="1B2538"/>
+                          </a:solidFill>
+                          <a:latin typeface="Calibri"/>
+                        </a:rPr>
+                        <a:t>— (missing sink + non-causal)</a:t>
+                      </a:r>
+                    </a:p>
+                  </a:txBody>
+                  <a:tcPr>
+                    <a:solidFill>
+                      <a:srgbClr val="FFFFFF"/>
+                    </a:solidFill>
+                  </a:tcPr>
+                </a:tc>
+              </a:tr>
+              <a:tr h="365760">
+                <a:tc>
+                  <a:txBody>
+                    <a:bodyPr/>
+                    <a:lstStyle/>
+                    <a:p>
+                      <a:r>
+                        <a:rPr sz="1200" b="0" i="0">
+                          <a:solidFill>
+                            <a:srgbClr val="1B2538"/>
+                          </a:solidFill>
+                          <a:latin typeface="Calibri"/>
+                        </a:rPr>
+                        <a:t>einsum (current training path)</a:t>
+                      </a:r>
+                    </a:p>
+                  </a:txBody>
+                  <a:tcPr>
+                    <a:solidFill>
+                      <a:srgbClr val="F5F7FA"/>
+                    </a:solidFill>
+                  </a:tcPr>
+                </a:tc>
+                <a:tc>
+                  <a:txBody>
+                    <a:bodyPr/>
+                    <a:lstStyle/>
+                    <a:p>
+                      <a:r>
+                        <a:rPr sz="1200" b="0" i="0">
+                          <a:solidFill>
+                            <a:srgbClr val="1B2538"/>
+                          </a:solidFill>
+                          <a:latin typeface="Calibri"/>
+                        </a:rPr>
+                        <a:t>✓</a:t>
+                      </a:r>
+                    </a:p>
+                  </a:txBody>
+                  <a:tcPr>
+                    <a:solidFill>
+                      <a:srgbClr val="F5F7FA"/>
+                    </a:solidFill>
+                  </a:tcPr>
+                </a:tc>
+                <a:tc>
+                  <a:txBody>
+                    <a:bodyPr/>
+                    <a:lstStyle/>
+                    <a:p>
+                      <a:r>
+                        <a:rPr sz="1200" b="0" i="0">
+                          <a:solidFill>
+                            <a:srgbClr val="1B2538"/>
+                          </a:solidFill>
+                          <a:latin typeface="Calibri"/>
+                        </a:rPr>
+                        <a:t>✓</a:t>
+                      </a:r>
+                    </a:p>
+                  </a:txBody>
+                  <a:tcPr>
+                    <a:solidFill>
+                      <a:srgbClr val="F5F7FA"/>
+                    </a:solidFill>
+                  </a:tcPr>
+                </a:tc>
+                <a:tc>
+                  <a:txBody>
+                    <a:bodyPr/>
+                    <a:lstStyle/>
+                    <a:p>
+                      <a:r>
+                        <a:rPr sz="1200" b="0" i="0">
+                          <a:solidFill>
+                            <a:srgbClr val="1B2538"/>
+                          </a:solidFill>
+                          <a:latin typeface="Calibri"/>
+                        </a:rPr>
+                        <a:t>✓</a:t>
+                      </a:r>
+                    </a:p>
+                  </a:txBody>
+                  <a:tcPr>
+                    <a:solidFill>
+                      <a:srgbClr val="F5F7FA"/>
+                    </a:solidFill>
+                  </a:tcPr>
+                </a:tc>
+                <a:tc>
+                  <a:txBody>
+                    <a:bodyPr/>
+                    <a:lstStyle/>
+                    <a:p>
+                      <a:r>
+                        <a:rPr sz="1200" b="0" i="0">
+                          <a:solidFill>
+                            <a:srgbClr val="1B2538"/>
+                          </a:solidFill>
+                          <a:latin typeface="Calibri"/>
+                        </a:rPr>
+                        <a:t>✓ slow</a:t>
+                      </a:r>
+                    </a:p>
+                  </a:txBody>
+                  <a:tcPr>
+                    <a:solidFill>
+                      <a:srgbClr val="F5F7FA"/>
+                    </a:solidFill>
+                  </a:tcPr>
+                </a:tc>
+                <a:tc>
+                  <a:txBody>
+                    <a:bodyPr/>
+                    <a:lstStyle/>
+                    <a:p>
+                      <a:r>
+                        <a:rPr sz="1200" b="0" i="0">
+                          <a:solidFill>
+                            <a:srgbClr val="1B2538"/>
+                          </a:solidFill>
+                          <a:latin typeface="Calibri"/>
+                        </a:rPr>
+                        <a:t>training now</a:t>
+                      </a:r>
+                    </a:p>
+                  </a:txBody>
+                  <a:tcPr>
+                    <a:solidFill>
+                      <a:srgbClr val="F5F7FA"/>
+                    </a:solidFill>
+                  </a:tcPr>
+                </a:tc>
+              </a:tr>
+              <a:tr h="365760">
+                <a:tc>
+                  <a:txBody>
+                    <a:bodyPr/>
+                    <a:lstStyle/>
+                    <a:p>
+                      <a:r>
+                        <a:rPr sz="1200" b="0" i="0">
+                          <a:solidFill>
+                            <a:srgbClr val="1B2538"/>
+                          </a:solidFill>
+                          <a:latin typeface="Calibri"/>
+                        </a:rPr>
+                        <a:t>Triton kernel (built)</a:t>
+                      </a:r>
+                    </a:p>
+                  </a:txBody>
+                  <a:tcPr>
+                    <a:solidFill>
+                      <a:srgbClr val="FFFFFF"/>
+                    </a:solidFill>
+                  </a:tcPr>
+                </a:tc>
+                <a:tc>
+                  <a:txBody>
+                    <a:bodyPr/>
+                    <a:lstStyle/>
+                    <a:p>
+                      <a:r>
+                        <a:rPr sz="1200" b="0" i="0">
+                          <a:solidFill>
+                            <a:srgbClr val="1B2538"/>
+                          </a:solidFill>
+                          <a:latin typeface="Calibri"/>
+                        </a:rPr>
+                        <a:t>✓</a:t>
+                      </a:r>
+                    </a:p>
+                  </a:txBody>
+                  <a:tcPr>
+                    <a:solidFill>
+                      <a:srgbClr val="FFFFFF"/>
+                    </a:solidFill>
+                  </a:tcPr>
+                </a:tc>
+                <a:tc>
+                  <a:txBody>
+                    <a:bodyPr/>
+                    <a:lstStyle/>
+                    <a:p>
+                      <a:r>
+                        <a:rPr sz="1200" b="0" i="0">
+                          <a:solidFill>
+                            <a:srgbClr val="1B2538"/>
+                          </a:solidFill>
+                          <a:latin typeface="Calibri"/>
+                        </a:rPr>
+                        <a:t>✓</a:t>
+                      </a:r>
+                    </a:p>
+                  </a:txBody>
+                  <a:tcPr>
+                    <a:solidFill>
+                      <a:srgbClr val="FFFFFF"/>
+                    </a:solidFill>
+                  </a:tcPr>
+                </a:tc>
+                <a:tc>
+                  <a:txBody>
+                    <a:bodyPr/>
+                    <a:lstStyle/>
+                    <a:p>
+                      <a:r>
+                        <a:rPr sz="1200" b="0" i="0">
+                          <a:solidFill>
+                            <a:srgbClr val="1B2538"/>
+                          </a:solidFill>
+                          <a:latin typeface="Calibri"/>
+                        </a:rPr>
+                        <a:t>✓</a:t>
+                      </a:r>
+                    </a:p>
+                  </a:txBody>
+                  <a:tcPr>
+                    <a:solidFill>
+                      <a:srgbClr val="FFFFFF"/>
+                    </a:solidFill>
+                  </a:tcPr>
+                </a:tc>
+                <a:tc>
+                  <a:txBody>
+                    <a:bodyPr/>
+                    <a:lstStyle/>
+                    <a:p>
+                      <a:r>
+                        <a:rPr sz="1200" b="0" i="0">
+                          <a:solidFill>
+                            <a:srgbClr val="1B2538"/>
+                          </a:solidFill>
+                          <a:latin typeface="Calibri"/>
+                        </a:rPr>
+                        <a:t>✓</a:t>
+                      </a:r>
+                    </a:p>
+                  </a:txBody>
+                  <a:tcPr>
+                    <a:solidFill>
+                      <a:srgbClr val="FFFFFF"/>
+                    </a:solidFill>
+                  </a:tcPr>
+                </a:tc>
+                <a:tc>
+                  <a:txBody>
+                    <a:bodyPr/>
+                    <a:lstStyle/>
+                    <a:p>
+                      <a:r>
+                        <a:rPr sz="1200" b="0" i="0">
+                          <a:solidFill>
+                            <a:srgbClr val="1B2538"/>
+                          </a:solidFill>
+                          <a:latin typeface="Calibri"/>
+                        </a:rPr>
+                        <a:t>training target — 5.96e-7 vs gold</a:t>
+                      </a:r>
+                    </a:p>
+                  </a:txBody>
+                  <a:tcPr>
+                    <a:solidFill>
+                      <a:srgbClr val="FFFFFF"/>
+                    </a:solidFill>
+                  </a:tcPr>
+                </a:tc>
+              </a:tr>
+            </a:tbl>
+          </a:graphicData>
+        </a:graphic>
+      </p:graphicFrame>
+      <p:sp>
+        <p:nvSpPr>
+          <p:cNvPr id="5" name="TextBox 4"/>
           <p:cNvSpPr txBox="1"/>
           <p:nvPr/>
         </p:nvSpPr>
         <p:spPr>
           <a:xfrm>
-            <a:off x="548640" y="1371600"/>
+            <a:off x="548640" y="4114800"/>
             <a:ext cx="11064240" cy="5120640"/>
           </a:xfrm>
           <a:prstGeom prst="rect">
@@ -4286,7 +4660,7 @@
                 </a:solidFill>
                 <a:latin typeface="Calibri"/>
               </a:rPr>
-              <a:t>Every module needs a correctness ORACLE, not just a smoke test. Status today:</a:t>
+              <a:t>No single fused op has all four — so training uses the (correct but slow) einsum; the Triton kernel fuses it.</a:t>
             </a:r>
           </a:p>
           <a:p>
@@ -4311,7 +4685,7 @@
                 </a:solidFill>
                 <a:latin typeface="Calibri"/>
               </a:rPr>
-              <a:t>GREEN (gold-standard oracle): MoE grouped-GEMM &amp; all-to-all parity, HF component parity, MLA ref, draft-attn vs gold, mHC Sinkhorn.</a:t>
+              <a:t>Triton kernel is done and validated (matches the gold reference at fp32 5.96e-7); needs integration into training.</a:t>
             </a:r>
           </a:p>
           <a:p>
@@ -4332,68 +4706,18 @@
             <a:r>
               <a:rPr sz="1600" b="0" i="0">
                 <a:solidFill>
-                  <a:srgbClr val="C05200"/>
-                </a:solidFill>
-                <a:latin typeface="Calibri"/>
-              </a:rPr>
-              <a:t>PENDING: assembled-draft numeric parity; structural weight-key parity vs the released draft; HS value-correctness.</a:t>
-            </a:r>
-          </a:p>
-          <a:p>
-            <a:pPr>
-              <a:spcAft>
-                <a:spcPts val="600"/>
-              </a:spcAft>
-            </a:pPr>
-            <a:r>
-              <a:rPr sz="1600" b="1" i="0">
-                <a:solidFill>
-                  <a:srgbClr val="2E6CF6"/>
-                </a:solidFill>
-                <a:latin typeface="Calibri"/>
-              </a:rPr>
-              <a:t>•  </a:t>
-            </a:r>
-            <a:r>
-              <a:rPr sz="1600" b="0" i="0">
-                <a:solidFill>
-                  <a:srgbClr val="C05200"/>
-                </a:solidFill>
-                <a:latin typeface="Calibri"/>
-              </a:rPr>
-              <a:t>Silently-wrong gates to add: EP-invariance (EP=1 vs 8), gradcheck on hand-written backward, overfit-one-batch, serve↔train config guard.</a:t>
-            </a:r>
-          </a:p>
-          <a:p>
-            <a:pPr>
-              <a:spcAft>
-                <a:spcPts val="600"/>
-              </a:spcAft>
-            </a:pPr>
-            <a:r>
-              <a:rPr sz="1600" b="1" i="0">
-                <a:solidFill>
-                  <a:srgbClr val="2E6CF6"/>
-                </a:solidFill>
-                <a:latin typeface="Calibri"/>
-              </a:rPr>
-              <a:t>•  </a:t>
-            </a:r>
-            <a:r>
-              <a:rPr sz="1600" b="0" i="0">
-                <a:solidFill>
                   <a:srgbClr val="1B2538"/>
                 </a:solidFill>
                 <a:latin typeface="Calibri"/>
               </a:rPr>
-              <a:t>Green-check runner tiered CPU / single-NPU / needs-serve; the block-size bug is exactly the kind the config guard catches.</a:t>
-            </a:r>
-          </a:p>
-        </p:txBody>
-      </p:sp>
-      <p:sp>
-        <p:nvSpPr>
-          <p:cNvPr id="5" name="TextBox 4"/>
+              <a:t>Real inference dispatches to the SAS op (source verified non-causal; #11196 relaxed the causal asserts).</a:t>
+            </a:r>
+          </a:p>
+        </p:txBody>
+      </p:sp>
+      <p:sp>
+        <p:nvSpPr>
+          <p:cNvPr id="6" name="TextBox 5"/>
           <p:cNvSpPr txBox="1"/>
           <p:nvPr/>
         </p:nvSpPr>
@@ -4524,7 +4848,7 @@
                 </a:solidFill>
                 <a:latin typeface="Calibri"/>
               </a:rPr>
-              <a:t>NEXT</a:t>
+              <a:t>VALIDATION</a:t>
             </a:r>
           </a:p>
           <a:p>
@@ -4535,7 +4859,7 @@
                 </a:solidFill>
                 <a:latin typeface="Calibri"/>
               </a:rPr>
-              <a:t>Remaining work / roadmap</a:t>
+              <a:t>Correctness validation — "it runs" ≠ "it's correct"</a:t>
             </a:r>
           </a:p>
         </p:txBody>
@@ -4580,11 +4904,11 @@
             <a:r>
               <a:rPr sz="1600" b="0" i="0">
                 <a:solidFill>
-                  <a:srgbClr val="2E6CF6"/>
-                </a:solidFill>
-                <a:latin typeface="Calibri"/>
-              </a:rPr>
-              <a:t>Throughput (biggest single win, ~3×): fixed-shape MoE padding (kills recompiles) + save once/epoch (done, one-liner).</a:t>
+                  <a:srgbClr val="1B2538"/>
+                </a:solidFill>
+                <a:latin typeface="Calibri"/>
+              </a:rPr>
+              <a:t>Every module needs a correctness ORACLE, not just a smoke test. Status today:</a:t>
             </a:r>
           </a:p>
           <a:p>
@@ -4605,11 +4929,11 @@
             <a:r>
               <a:rPr sz="1600" b="0" i="0">
                 <a:solidFill>
-                  <a:srgbClr val="2E6CF6"/>
-                </a:solidFill>
-                <a:latin typeface="Calibri"/>
-              </a:rPr>
-              <a:t>Critical path: stacked→per-expert weight converter (unblocks serve/eval) → full train→eval → fill converged numbers.</a:t>
+                  <a:srgbClr val="1B8A4E"/>
+                </a:solidFill>
+                <a:latin typeface="Calibri"/>
+              </a:rPr>
+              <a:t>GREEN (gold-standard oracle): MoE grouped-GEMM &amp; all-to-all parity, HF component parity, MLA ref, draft-attn vs gold, mHC Sinkhorn.</a:t>
             </a:r>
           </a:p>
           <a:p>
@@ -4630,11 +4954,11 @@
             <a:r>
               <a:rPr sz="1600" b="0" i="0">
                 <a:solidFill>
-                  <a:srgbClr val="1B2538"/>
-                </a:solidFill>
-                <a:latin typeface="Calibri"/>
-              </a:rPr>
-              <a:t>Validation gates (cheap, CPU): structural parity · EP-invariance · overfit-one-batch · config guard.</a:t>
+                  <a:srgbClr val="C05200"/>
+                </a:solidFill>
+                <a:latin typeface="Calibri"/>
+              </a:rPr>
+              <a:t>PENDING: assembled-draft numeric parity; structural weight-key parity vs the released draft; HS value-correctness.</a:t>
             </a:r>
           </a:p>
           <a:p>
@@ -4655,11 +4979,11 @@
             <a:r>
               <a:rPr sz="1600" b="0" i="0">
                 <a:solidFill>
-                  <a:srgbClr val="1B2538"/>
-                </a:solidFill>
-                <a:latin typeface="Calibri"/>
-              </a:rPr>
-              <a:t>Perf follow-ups: argsort AiCore fix · gradient checkpointing (→512 anchors) · SWA Triton kernel into training.</a:t>
+                  <a:srgbClr val="C05200"/>
+                </a:solidFill>
+                <a:latin typeface="Calibri"/>
+              </a:rPr>
+              <a:t>Silently-wrong gates to add: EP-invariance (EP=1 vs 8), gradcheck on hand-written backward, overfit-one-batch, serve↔train config guard.</a:t>
             </a:r>
           </a:p>
           <a:p>
@@ -4684,32 +5008,7 @@
                 </a:solidFill>
                 <a:latin typeface="Calibri"/>
               </a:rPr>
-              <a:t>Upstream: carve the DTensor-native EP refactor into a clean GPU-safe PR.</a:t>
-            </a:r>
-          </a:p>
-          <a:p>
-            <a:pPr>
-              <a:spcAft>
-                <a:spcPts val="600"/>
-              </a:spcAft>
-            </a:pPr>
-            <a:r>
-              <a:rPr sz="1600" b="1" i="0">
-                <a:solidFill>
-                  <a:srgbClr val="2E6CF6"/>
-                </a:solidFill>
-                <a:latin typeface="Calibri"/>
-              </a:rPr>
-              <a:t>•  </a:t>
-            </a:r>
-            <a:r>
-              <a:rPr sz="1600" b="0" i="0">
-                <a:solidFill>
-                  <a:srgbClr val="5A6678"/>
-                </a:solidFill>
-                <a:latin typeface="Calibri"/>
-              </a:rPr>
-              <a:t>Deferred: native extract HS path (needs vLLM 0.24 + the DP0/head memory pathology solved).</a:t>
+              <a:t>Green-check runner tiered CPU / single-NPU / needs-serve; the block-size bug is exactly the kind the config guard catches.</a:t>
             </a:r>
           </a:p>
         </p:txBody>
@@ -4847,7 +5146,7 @@
                 </a:solidFill>
                 <a:latin typeface="Calibri"/>
               </a:rPr>
-              <a:t>SOURCES</a:t>
+              <a:t>NEXT</a:t>
             </a:r>
           </a:p>
           <a:p>
@@ -4858,7 +5157,7 @@
                 </a:solidFill>
                 <a:latin typeface="Calibri"/>
               </a:rPr>
-              <a:t>Reproducibility &amp; provenance</a:t>
+              <a:t>Remaining work / roadmap</a:t>
             </a:r>
           </a:p>
         </p:txBody>
@@ -4903,11 +5202,11 @@
             <a:r>
               <a:rPr sz="1600" b="0" i="0">
                 <a:solidFill>
-                  <a:srgbClr val="1B2538"/>
-                </a:solidFill>
-                <a:latin typeface="Calibri"/>
-              </a:rPr>
-              <a:t>Every load-bearing claim is tied to a file:line / released config field / PR / paper — see the design doc §1.5 + §10.</a:t>
+                  <a:srgbClr val="2E6CF6"/>
+                </a:solidFill>
+                <a:latin typeface="Calibri"/>
+              </a:rPr>
+              <a:t>Throughput (biggest single win, ~3×): fixed-shape MoE padding (kills recompiles) + save once/epoch (done, one-liner).</a:t>
             </a:r>
           </a:p>
           <a:p>
@@ -4928,11 +5227,11 @@
             <a:r>
               <a:rPr sz="1600" b="0" i="0">
                 <a:solidFill>
-                  <a:srgbClr val="1B2538"/>
-                </a:solidFill>
-                <a:latin typeface="Calibri"/>
-              </a:rPr>
-              <a:t>Design &amp; results: docs/deployment/ascend-npu-dsv4-dspark-ep-training.md  (branch feat/dsv4-dspark).</a:t>
+                  <a:srgbClr val="2E6CF6"/>
+                </a:solidFill>
+                <a:latin typeface="Calibri"/>
+              </a:rPr>
+              <a:t>Critical path: stacked→per-expert weight converter (unblocks serve/eval) → full train→eval → fill converged numbers.</a:t>
             </a:r>
           </a:p>
           <a:p>
@@ -4957,7 +5256,7 @@
                 </a:solidFill>
                 <a:latin typeface="Calibri"/>
               </a:rPr>
-              <a:t>Pipeline index + per-stage archive: docs/deployment/ascend-npu-dsv4-dspark-pipeline.md.</a:t>
+              <a:t>Validation gates (cheap, CPU): structural parity · EP-invariance · overfit-one-batch · config guard.</a:t>
             </a:r>
           </a:p>
           <a:p>
@@ -4982,7 +5281,7 @@
                 </a:solidFill>
                 <a:latin typeface="Calibri"/>
               </a:rPr>
-              <a:t>HS extraction deep-dive: ascend-npu-dsv4-hs-dumper-planB.md.</a:t>
+              <a:t>Perf follow-ups: argsort AiCore fix · gradient checkpointing (→512 anchors) · SWA Triton kernel into training.</a:t>
             </a:r>
           </a:p>
           <a:p>
@@ -5007,7 +5306,7 @@
                 </a:solidFill>
                 <a:latin typeface="Calibri"/>
               </a:rPr>
-              <a:t>Repos: Sawyer117/speculators (trainer) · Sawyer117/vllm-ascend @ feat/dsv4-hs-dumper (serve+HS) · non-causal-swa-triton-ascend (kernel).</a:t>
+              <a:t>Upstream: carve the DTensor-native EP refactor into a clean GPU-safe PR.</a:t>
             </a:r>
           </a:p>
           <a:p>
@@ -5028,11 +5327,11 @@
             <a:r>
               <a:rPr sz="1600" b="0" i="0">
                 <a:solidFill>
-                  <a:srgbClr val="1B2538"/>
-                </a:solidFill>
-                <a:latin typeface="Calibri"/>
-              </a:rPr>
-              <a:t>Log analysis: examples/ascend_npu_dflash/analyze_train_run.py (loss / accept / confidence / timing / spikes + plots).</a:t>
+                  <a:srgbClr val="5A6678"/>
+                </a:solidFill>
+                <a:latin typeface="Calibri"/>
+              </a:rPr>
+              <a:t>Deferred: native extract HS path (needs vLLM 0.24 + the DP0/head memory pathology solved).</a:t>
             </a:r>
           </a:p>
         </p:txBody>
@@ -5068,6 +5367,329 @@
                 <a:latin typeface="Calibri"/>
               </a:rPr>
               <a:t>DSV4-DSpark · NPU · 13</a:t>
+            </a:r>
+          </a:p>
+        </p:txBody>
+      </p:sp>
+    </p:spTree>
+  </p:cSld>
+  <p:clrMapOvr>
+    <a:masterClrMapping/>
+  </p:clrMapOvr>
+</p:sld>
+</file>
+
+<file path=ppt/slides/slide14.xml><?xml version="1.0" encoding="utf-8"?>
+<p:sld xmlns:a="http://schemas.openxmlformats.org/drawingml/2006/main" xmlns:p="http://schemas.openxmlformats.org/presentationml/2006/main" xmlns:r="http://schemas.openxmlformats.org/officeDocument/2006/relationships">
+  <p:cSld>
+    <p:bg>
+      <p:bgPr>
+        <a:solidFill>
+          <a:srgbClr val="FFFFFF"/>
+        </a:solidFill>
+        <a:effectLst/>
+      </p:bgPr>
+    </p:bg>
+    <p:spTree>
+      <p:nvGrpSpPr>
+        <p:cNvPr id="1" name=""/>
+        <p:cNvGrpSpPr/>
+        <p:nvPr/>
+      </p:nvGrpSpPr>
+      <p:grpSpPr/>
+      <p:sp>
+        <p:nvSpPr>
+          <p:cNvPr id="2" name="Rectangle 1"/>
+          <p:cNvSpPr/>
+          <p:nvPr/>
+        </p:nvSpPr>
+        <p:spPr>
+          <a:xfrm>
+            <a:off x="0" y="0"/>
+            <a:ext cx="12191695" cy="1051560"/>
+          </a:xfrm>
+          <a:prstGeom prst="rect">
+            <a:avLst/>
+          </a:prstGeom>
+          <a:solidFill>
+            <a:srgbClr val="1B2538"/>
+          </a:solidFill>
+          <a:ln>
+            <a:noFill/>
+          </a:ln>
+        </p:spPr>
+        <p:style>
+          <a:lnRef idx="1">
+            <a:schemeClr val="accent1"/>
+          </a:lnRef>
+          <a:fillRef idx="3">
+            <a:schemeClr val="accent1"/>
+          </a:fillRef>
+          <a:effectRef idx="2">
+            <a:schemeClr val="accent1"/>
+          </a:effectRef>
+          <a:fontRef idx="minor">
+            <a:schemeClr val="lt1"/>
+          </a:fontRef>
+        </p:style>
+        <p:txBody>
+          <a:bodyPr rtlCol="0" anchor="ctr"/>
+          <a:lstStyle/>
+          <a:p>
+            <a:pPr algn="ctr"/>
+          </a:p>
+        </p:txBody>
+      </p:sp>
+      <p:sp>
+        <p:nvSpPr>
+          <p:cNvPr id="3" name="TextBox 2"/>
+          <p:cNvSpPr txBox="1"/>
+          <p:nvPr/>
+        </p:nvSpPr>
+        <p:spPr>
+          <a:xfrm>
+            <a:off x="502920" y="128016"/>
+            <a:ext cx="11155680" cy="868680"/>
+          </a:xfrm>
+          <a:prstGeom prst="rect">
+            <a:avLst/>
+          </a:prstGeom>
+          <a:noFill/>
+        </p:spPr>
+        <p:txBody>
+          <a:bodyPr wrap="square">
+            <a:spAutoFit/>
+          </a:bodyPr>
+          <a:lstStyle/>
+          <a:p>
+            <a:r>
+              <a:rPr sz="1200" b="1" i="0">
+                <a:solidFill>
+                  <a:srgbClr val="8FB6FF"/>
+                </a:solidFill>
+                <a:latin typeface="Calibri"/>
+              </a:rPr>
+              <a:t>SOURCES</a:t>
+            </a:r>
+          </a:p>
+          <a:p>
+            <a:r>
+              <a:rPr sz="2600" b="1" i="0">
+                <a:solidFill>
+                  <a:srgbClr val="FFFFFF"/>
+                </a:solidFill>
+                <a:latin typeface="Calibri"/>
+              </a:rPr>
+              <a:t>Reproducibility &amp; provenance</a:t>
+            </a:r>
+          </a:p>
+        </p:txBody>
+      </p:sp>
+      <p:sp>
+        <p:nvSpPr>
+          <p:cNvPr id="4" name="TextBox 3"/>
+          <p:cNvSpPr txBox="1"/>
+          <p:nvPr/>
+        </p:nvSpPr>
+        <p:spPr>
+          <a:xfrm>
+            <a:off x="548640" y="1371600"/>
+            <a:ext cx="11064240" cy="5120640"/>
+          </a:xfrm>
+          <a:prstGeom prst="rect">
+            <a:avLst/>
+          </a:prstGeom>
+          <a:noFill/>
+        </p:spPr>
+        <p:txBody>
+          <a:bodyPr wrap="square">
+            <a:spAutoFit/>
+          </a:bodyPr>
+          <a:lstStyle/>
+          <a:p/>
+          <a:p>
+            <a:pPr>
+              <a:spcAft>
+                <a:spcPts val="600"/>
+              </a:spcAft>
+            </a:pPr>
+            <a:r>
+              <a:rPr sz="1600" b="1" i="0">
+                <a:solidFill>
+                  <a:srgbClr val="2E6CF6"/>
+                </a:solidFill>
+                <a:latin typeface="Calibri"/>
+              </a:rPr>
+              <a:t>•  </a:t>
+            </a:r>
+            <a:r>
+              <a:rPr sz="1600" b="0" i="0">
+                <a:solidFill>
+                  <a:srgbClr val="1B2538"/>
+                </a:solidFill>
+                <a:latin typeface="Calibri"/>
+              </a:rPr>
+              <a:t>Every load-bearing claim is tied to a file:line / released config field / PR / paper — see the design doc §1.5 + §10.</a:t>
+            </a:r>
+          </a:p>
+          <a:p>
+            <a:pPr>
+              <a:spcAft>
+                <a:spcPts val="600"/>
+              </a:spcAft>
+            </a:pPr>
+            <a:r>
+              <a:rPr sz="1600" b="1" i="0">
+                <a:solidFill>
+                  <a:srgbClr val="2E6CF6"/>
+                </a:solidFill>
+                <a:latin typeface="Calibri"/>
+              </a:rPr>
+              <a:t>•  </a:t>
+            </a:r>
+            <a:r>
+              <a:rPr sz="1600" b="0" i="0">
+                <a:solidFill>
+                  <a:srgbClr val="1B2538"/>
+                </a:solidFill>
+                <a:latin typeface="Calibri"/>
+              </a:rPr>
+              <a:t>Design &amp; results: docs/deployment/ascend-npu-dsv4-dspark-ep-training.md  (branch feat/dsv4-dspark).</a:t>
+            </a:r>
+          </a:p>
+          <a:p>
+            <a:pPr>
+              <a:spcAft>
+                <a:spcPts val="600"/>
+              </a:spcAft>
+            </a:pPr>
+            <a:r>
+              <a:rPr sz="1600" b="1" i="0">
+                <a:solidFill>
+                  <a:srgbClr val="2E6CF6"/>
+                </a:solidFill>
+                <a:latin typeface="Calibri"/>
+              </a:rPr>
+              <a:t>•  </a:t>
+            </a:r>
+            <a:r>
+              <a:rPr sz="1600" b="0" i="0">
+                <a:solidFill>
+                  <a:srgbClr val="1B2538"/>
+                </a:solidFill>
+                <a:latin typeface="Calibri"/>
+              </a:rPr>
+              <a:t>Pipeline index + per-stage archive: docs/deployment/ascend-npu-dsv4-dspark-pipeline.md.</a:t>
+            </a:r>
+          </a:p>
+          <a:p>
+            <a:pPr>
+              <a:spcAft>
+                <a:spcPts val="600"/>
+              </a:spcAft>
+            </a:pPr>
+            <a:r>
+              <a:rPr sz="1600" b="1" i="0">
+                <a:solidFill>
+                  <a:srgbClr val="2E6CF6"/>
+                </a:solidFill>
+                <a:latin typeface="Calibri"/>
+              </a:rPr>
+              <a:t>•  </a:t>
+            </a:r>
+            <a:r>
+              <a:rPr sz="1600" b="0" i="0">
+                <a:solidFill>
+                  <a:srgbClr val="1B2538"/>
+                </a:solidFill>
+                <a:latin typeface="Calibri"/>
+              </a:rPr>
+              <a:t>HS extraction deep-dive: ascend-npu-dsv4-hs-dumper-planB.md.</a:t>
+            </a:r>
+          </a:p>
+          <a:p>
+            <a:pPr>
+              <a:spcAft>
+                <a:spcPts val="600"/>
+              </a:spcAft>
+            </a:pPr>
+            <a:r>
+              <a:rPr sz="1600" b="1" i="0">
+                <a:solidFill>
+                  <a:srgbClr val="2E6CF6"/>
+                </a:solidFill>
+                <a:latin typeface="Calibri"/>
+              </a:rPr>
+              <a:t>•  </a:t>
+            </a:r>
+            <a:r>
+              <a:rPr sz="1600" b="0" i="0">
+                <a:solidFill>
+                  <a:srgbClr val="1B2538"/>
+                </a:solidFill>
+                <a:latin typeface="Calibri"/>
+              </a:rPr>
+              <a:t>Repos: Sawyer117/speculators (trainer) · Sawyer117/vllm-ascend @ feat/dsv4-hs-dumper (serve+HS) · non-causal-swa-triton-ascend (kernel).</a:t>
+            </a:r>
+          </a:p>
+          <a:p>
+            <a:pPr>
+              <a:spcAft>
+                <a:spcPts val="600"/>
+              </a:spcAft>
+            </a:pPr>
+            <a:r>
+              <a:rPr sz="1600" b="1" i="0">
+                <a:solidFill>
+                  <a:srgbClr val="2E6CF6"/>
+                </a:solidFill>
+                <a:latin typeface="Calibri"/>
+              </a:rPr>
+              <a:t>•  </a:t>
+            </a:r>
+            <a:r>
+              <a:rPr sz="1600" b="0" i="0">
+                <a:solidFill>
+                  <a:srgbClr val="1B2538"/>
+                </a:solidFill>
+                <a:latin typeface="Calibri"/>
+              </a:rPr>
+              <a:t>Log analysis: examples/ascend_npu_dflash/analyze_train_run.py (loss / accept / confidence / timing / spikes + plots).</a:t>
+            </a:r>
+          </a:p>
+        </p:txBody>
+      </p:sp>
+      <p:sp>
+        <p:nvSpPr>
+          <p:cNvPr id="5" name="TextBox 4"/>
+          <p:cNvSpPr txBox="1"/>
+          <p:nvPr/>
+        </p:nvSpPr>
+        <p:spPr>
+          <a:xfrm>
+            <a:off x="10424160" y="6419088"/>
+            <a:ext cx="1554480" cy="365760"/>
+          </a:xfrm>
+          <a:prstGeom prst="rect">
+            <a:avLst/>
+          </a:prstGeom>
+          <a:noFill/>
+        </p:spPr>
+        <p:txBody>
+          <a:bodyPr wrap="square">
+            <a:spAutoFit/>
+          </a:bodyPr>
+          <a:lstStyle/>
+          <a:p>
+            <a:pPr algn="r"/>
+            <a:r>
+              <a:rPr sz="900" b="0" i="0">
+                <a:solidFill>
+                  <a:srgbClr val="5A6678"/>
+                </a:solidFill>
+                <a:latin typeface="Calibri"/>
+              </a:rPr>
+              <a:t>DSV4-DSpark · NPU · 14</a:t>
             </a:r>
           </a:p>
         </p:txBody>

</xml_diff>